<commit_message>
Boton Volver en el Anexo + PDF resumen (20 diapositivas)
</commit_message>
<xml_diff>
--- a/Reforma_PJ_2026.pptx
+++ b/Reforma_PJ_2026.pptx
@@ -20613,7 +20613,62 @@
       </p:sp>
       <p:sp>
         <p:nvSpPr>
-          <p:cNvPr id="7" name="Rectangle 6"/>
+          <p:cNvPr id="7" name="Rounded Rectangle 6">
+            <a:hlinkClick action="ppaction://hlinksldjump" r:id="rId3"/>
+          </p:cNvPr>
+          <p:cNvSpPr/>
+          <p:nvPr/>
+        </p:nvSpPr>
+        <p:spPr>
+          <a:xfrm>
+            <a:off x="9128455" y="457200"/>
+            <a:ext cx="2514600" cy="329184"/>
+          </a:xfrm>
+          <a:prstGeom prst="roundRect">
+            <a:avLst/>
+          </a:prstGeom>
+          <a:solidFill>
+            <a:srgbClr val="6B1531"/>
+          </a:solidFill>
+          <a:ln>
+            <a:noFill/>
+          </a:ln>
+          <a:effectLst/>
+        </p:spPr>
+        <p:style>
+          <a:lnRef idx="1">
+            <a:schemeClr val="accent1"/>
+          </a:lnRef>
+          <a:fillRef idx="3">
+            <a:schemeClr val="accent1"/>
+          </a:fillRef>
+          <a:effectRef idx="2">
+            <a:schemeClr val="accent1"/>
+          </a:effectRef>
+          <a:fontRef idx="minor">
+            <a:schemeClr val="lt1"/>
+          </a:fontRef>
+        </p:style>
+        <p:txBody>
+          <a:bodyPr rtlCol="0" anchor="ctr" lIns="0" rIns="0"/>
+          <a:lstStyle/>
+          <a:p>
+            <a:pPr algn="ctr"/>
+            <a:r>
+              <a:rPr sz="1100" b="1">
+                <a:solidFill>
+                  <a:srgbClr val="FFFFFF"/>
+                </a:solidFill>
+                <a:latin typeface="Montserrat"/>
+              </a:rPr>
+              <a:t>&lt; Volver al comparativo</a:t>
+            </a:r>
+          </a:p>
+        </p:txBody>
+      </p:sp>
+      <p:sp>
+        <p:nvSpPr>
+          <p:cNvPr id="8" name="Rectangle 7"/>
           <p:cNvSpPr/>
           <p:nvPr/>
         </p:nvSpPr>
@@ -20657,7 +20712,7 @@
       </p:sp>
       <p:sp>
         <p:nvSpPr>
-          <p:cNvPr id="8" name="Rectangle 7"/>
+          <p:cNvPr id="9" name="Rectangle 8"/>
           <p:cNvSpPr/>
           <p:nvPr/>
         </p:nvSpPr>
@@ -20701,7 +20756,7 @@
       </p:sp>
       <p:sp>
         <p:nvSpPr>
-          <p:cNvPr id="9" name="TextBox 8"/>
+          <p:cNvPr id="10" name="TextBox 9"/>
           <p:cNvSpPr txBox="1"/>
           <p:nvPr/>
         </p:nvSpPr>
@@ -20740,7 +20795,7 @@
       </p:sp>
       <p:sp>
         <p:nvSpPr>
-          <p:cNvPr id="10" name="TextBox 9"/>
+          <p:cNvPr id="11" name="TextBox 10"/>
           <p:cNvSpPr txBox="1"/>
           <p:nvPr/>
         </p:nvSpPr>
@@ -20877,7 +20932,7 @@
       </p:sp>
       <p:sp>
         <p:nvSpPr>
-          <p:cNvPr id="11" name="Rectangle 10"/>
+          <p:cNvPr id="12" name="Rectangle 11"/>
           <p:cNvSpPr/>
           <p:nvPr/>
         </p:nvSpPr>
@@ -20921,7 +20976,7 @@
       </p:sp>
       <p:sp>
         <p:nvSpPr>
-          <p:cNvPr id="12" name="Rectangle 11"/>
+          <p:cNvPr id="13" name="Rectangle 12"/>
           <p:cNvSpPr/>
           <p:nvPr/>
         </p:nvSpPr>
@@ -20965,7 +21020,7 @@
       </p:sp>
       <p:sp>
         <p:nvSpPr>
-          <p:cNvPr id="13" name="TextBox 12"/>
+          <p:cNvPr id="14" name="TextBox 13"/>
           <p:cNvSpPr txBox="1"/>
           <p:nvPr/>
         </p:nvSpPr>
@@ -21004,7 +21059,7 @@
       </p:sp>
       <p:sp>
         <p:nvSpPr>
-          <p:cNvPr id="14" name="TextBox 13"/>
+          <p:cNvPr id="15" name="TextBox 14"/>
           <p:cNvSpPr txBox="1"/>
           <p:nvPr/>
         </p:nvSpPr>
@@ -21141,7 +21196,7 @@
       </p:sp>
       <p:sp>
         <p:nvSpPr>
-          <p:cNvPr id="15" name="TextBox 14"/>
+          <p:cNvPr id="16" name="TextBox 15"/>
           <p:cNvSpPr txBox="1"/>
           <p:nvPr/>
         </p:nvSpPr>
@@ -21176,7 +21231,7 @@
       </p:sp>
       <p:sp>
         <p:nvSpPr>
-          <p:cNvPr id="16" name="Rectangle 15"/>
+          <p:cNvPr id="17" name="Rectangle 16"/>
           <p:cNvSpPr/>
           <p:nvPr/>
         </p:nvSpPr>
@@ -21220,7 +21275,7 @@
       </p:sp>
       <p:sp>
         <p:nvSpPr>
-          <p:cNvPr id="17" name="Rectangle 16"/>
+          <p:cNvPr id="18" name="Rectangle 17"/>
           <p:cNvSpPr/>
           <p:nvPr/>
         </p:nvSpPr>
@@ -21264,7 +21319,7 @@
       </p:sp>
       <p:sp>
         <p:nvSpPr>
-          <p:cNvPr id="18" name="TextBox 17"/>
+          <p:cNvPr id="19" name="TextBox 18"/>
           <p:cNvSpPr txBox="1"/>
           <p:nvPr/>
         </p:nvSpPr>
@@ -21303,7 +21358,7 @@
       </p:sp>
       <p:sp>
         <p:nvSpPr>
-          <p:cNvPr id="19" name="TextBox 18"/>
+          <p:cNvPr id="20" name="TextBox 19"/>
           <p:cNvSpPr txBox="1"/>
           <p:nvPr/>
         </p:nvSpPr>
@@ -21584,7 +21639,62 @@
       </p:sp>
       <p:sp>
         <p:nvSpPr>
-          <p:cNvPr id="7" name="Rectangle 6"/>
+          <p:cNvPr id="7" name="Rounded Rectangle 6">
+            <a:hlinkClick action="ppaction://hlinksldjump" r:id="rId3"/>
+          </p:cNvPr>
+          <p:cNvSpPr/>
+          <p:nvPr/>
+        </p:nvSpPr>
+        <p:spPr>
+          <a:xfrm>
+            <a:off x="9128455" y="457200"/>
+            <a:ext cx="2514600" cy="329184"/>
+          </a:xfrm>
+          <a:prstGeom prst="roundRect">
+            <a:avLst/>
+          </a:prstGeom>
+          <a:solidFill>
+            <a:srgbClr val="6B1531"/>
+          </a:solidFill>
+          <a:ln>
+            <a:noFill/>
+          </a:ln>
+          <a:effectLst/>
+        </p:spPr>
+        <p:style>
+          <a:lnRef idx="1">
+            <a:schemeClr val="accent1"/>
+          </a:lnRef>
+          <a:fillRef idx="3">
+            <a:schemeClr val="accent1"/>
+          </a:fillRef>
+          <a:effectRef idx="2">
+            <a:schemeClr val="accent1"/>
+          </a:effectRef>
+          <a:fontRef idx="minor">
+            <a:schemeClr val="lt1"/>
+          </a:fontRef>
+        </p:style>
+        <p:txBody>
+          <a:bodyPr rtlCol="0" anchor="ctr" lIns="0" rIns="0"/>
+          <a:lstStyle/>
+          <a:p>
+            <a:pPr algn="ctr"/>
+            <a:r>
+              <a:rPr sz="1100" b="1">
+                <a:solidFill>
+                  <a:srgbClr val="FFFFFF"/>
+                </a:solidFill>
+                <a:latin typeface="Montserrat"/>
+              </a:rPr>
+              <a:t>&lt; Volver al comparativo</a:t>
+            </a:r>
+          </a:p>
+        </p:txBody>
+      </p:sp>
+      <p:sp>
+        <p:nvSpPr>
+          <p:cNvPr id="8" name="Rectangle 7"/>
           <p:cNvSpPr/>
           <p:nvPr/>
         </p:nvSpPr>
@@ -21628,7 +21738,7 @@
       </p:sp>
       <p:sp>
         <p:nvSpPr>
-          <p:cNvPr id="8" name="Rectangle 7"/>
+          <p:cNvPr id="9" name="Rectangle 8"/>
           <p:cNvSpPr/>
           <p:nvPr/>
         </p:nvSpPr>
@@ -21672,7 +21782,7 @@
       </p:sp>
       <p:sp>
         <p:nvSpPr>
-          <p:cNvPr id="9" name="TextBox 8"/>
+          <p:cNvPr id="10" name="TextBox 9"/>
           <p:cNvSpPr txBox="1"/>
           <p:nvPr/>
         </p:nvSpPr>
@@ -21711,7 +21821,7 @@
       </p:sp>
       <p:sp>
         <p:nvSpPr>
-          <p:cNvPr id="10" name="TextBox 9"/>
+          <p:cNvPr id="11" name="TextBox 10"/>
           <p:cNvSpPr txBox="1"/>
           <p:nvPr/>
         </p:nvSpPr>
@@ -21847,7 +21957,7 @@
       </p:sp>
       <p:sp>
         <p:nvSpPr>
-          <p:cNvPr id="11" name="Rectangle 10"/>
+          <p:cNvPr id="12" name="Rectangle 11"/>
           <p:cNvSpPr/>
           <p:nvPr/>
         </p:nvSpPr>
@@ -21891,7 +22001,7 @@
       </p:sp>
       <p:sp>
         <p:nvSpPr>
-          <p:cNvPr id="12" name="Rectangle 11"/>
+          <p:cNvPr id="13" name="Rectangle 12"/>
           <p:cNvSpPr/>
           <p:nvPr/>
         </p:nvSpPr>
@@ -21935,7 +22045,7 @@
       </p:sp>
       <p:sp>
         <p:nvSpPr>
-          <p:cNvPr id="13" name="TextBox 12"/>
+          <p:cNvPr id="14" name="TextBox 13"/>
           <p:cNvSpPr txBox="1"/>
           <p:nvPr/>
         </p:nvSpPr>
@@ -21974,7 +22084,7 @@
       </p:sp>
       <p:sp>
         <p:nvSpPr>
-          <p:cNvPr id="14" name="TextBox 13"/>
+          <p:cNvPr id="15" name="TextBox 14"/>
           <p:cNvSpPr txBox="1"/>
           <p:nvPr/>
         </p:nvSpPr>
@@ -22110,7 +22220,7 @@
       </p:sp>
       <p:sp>
         <p:nvSpPr>
-          <p:cNvPr id="15" name="TextBox 14"/>
+          <p:cNvPr id="16" name="TextBox 15"/>
           <p:cNvSpPr txBox="1"/>
           <p:nvPr/>
         </p:nvSpPr>
@@ -22145,7 +22255,7 @@
       </p:sp>
       <p:sp>
         <p:nvSpPr>
-          <p:cNvPr id="16" name="Rectangle 15"/>
+          <p:cNvPr id="17" name="Rectangle 16"/>
           <p:cNvSpPr/>
           <p:nvPr/>
         </p:nvSpPr>
@@ -22189,7 +22299,7 @@
       </p:sp>
       <p:sp>
         <p:nvSpPr>
-          <p:cNvPr id="17" name="Rectangle 16"/>
+          <p:cNvPr id="18" name="Rectangle 17"/>
           <p:cNvSpPr/>
           <p:nvPr/>
         </p:nvSpPr>
@@ -22233,7 +22343,7 @@
       </p:sp>
       <p:sp>
         <p:nvSpPr>
-          <p:cNvPr id="18" name="TextBox 17"/>
+          <p:cNvPr id="19" name="TextBox 18"/>
           <p:cNvSpPr txBox="1"/>
           <p:nvPr/>
         </p:nvSpPr>
@@ -22272,7 +22382,7 @@
       </p:sp>
       <p:sp>
         <p:nvSpPr>
-          <p:cNvPr id="19" name="TextBox 18"/>
+          <p:cNvPr id="20" name="TextBox 19"/>
           <p:cNvSpPr txBox="1"/>
           <p:nvPr/>
         </p:nvSpPr>
@@ -22553,7 +22663,62 @@
       </p:sp>
       <p:sp>
         <p:nvSpPr>
-          <p:cNvPr id="7" name="Rectangle 6"/>
+          <p:cNvPr id="7" name="Rounded Rectangle 6">
+            <a:hlinkClick action="ppaction://hlinksldjump" r:id="rId3"/>
+          </p:cNvPr>
+          <p:cNvSpPr/>
+          <p:nvPr/>
+        </p:nvSpPr>
+        <p:spPr>
+          <a:xfrm>
+            <a:off x="9128455" y="457200"/>
+            <a:ext cx="2514600" cy="329184"/>
+          </a:xfrm>
+          <a:prstGeom prst="roundRect">
+            <a:avLst/>
+          </a:prstGeom>
+          <a:solidFill>
+            <a:srgbClr val="6B1531"/>
+          </a:solidFill>
+          <a:ln>
+            <a:noFill/>
+          </a:ln>
+          <a:effectLst/>
+        </p:spPr>
+        <p:style>
+          <a:lnRef idx="1">
+            <a:schemeClr val="accent1"/>
+          </a:lnRef>
+          <a:fillRef idx="3">
+            <a:schemeClr val="accent1"/>
+          </a:fillRef>
+          <a:effectRef idx="2">
+            <a:schemeClr val="accent1"/>
+          </a:effectRef>
+          <a:fontRef idx="minor">
+            <a:schemeClr val="lt1"/>
+          </a:fontRef>
+        </p:style>
+        <p:txBody>
+          <a:bodyPr rtlCol="0" anchor="ctr" lIns="0" rIns="0"/>
+          <a:lstStyle/>
+          <a:p>
+            <a:pPr algn="ctr"/>
+            <a:r>
+              <a:rPr sz="1100" b="1">
+                <a:solidFill>
+                  <a:srgbClr val="FFFFFF"/>
+                </a:solidFill>
+                <a:latin typeface="Montserrat"/>
+              </a:rPr>
+              <a:t>&lt; Volver al comparativo</a:t>
+            </a:r>
+          </a:p>
+        </p:txBody>
+      </p:sp>
+      <p:sp>
+        <p:nvSpPr>
+          <p:cNvPr id="8" name="Rectangle 7"/>
           <p:cNvSpPr/>
           <p:nvPr/>
         </p:nvSpPr>
@@ -22597,7 +22762,7 @@
       </p:sp>
       <p:sp>
         <p:nvSpPr>
-          <p:cNvPr id="8" name="Rectangle 7"/>
+          <p:cNvPr id="9" name="Rectangle 8"/>
           <p:cNvSpPr/>
           <p:nvPr/>
         </p:nvSpPr>
@@ -22641,7 +22806,7 @@
       </p:sp>
       <p:sp>
         <p:nvSpPr>
-          <p:cNvPr id="9" name="TextBox 8"/>
+          <p:cNvPr id="10" name="TextBox 9"/>
           <p:cNvSpPr txBox="1"/>
           <p:nvPr/>
         </p:nvSpPr>
@@ -22680,7 +22845,7 @@
       </p:sp>
       <p:sp>
         <p:nvSpPr>
-          <p:cNvPr id="10" name="TextBox 9"/>
+          <p:cNvPr id="11" name="TextBox 10"/>
           <p:cNvSpPr txBox="1"/>
           <p:nvPr/>
         </p:nvSpPr>
@@ -22779,7 +22944,7 @@
       </p:sp>
       <p:sp>
         <p:nvSpPr>
-          <p:cNvPr id="11" name="Rectangle 10"/>
+          <p:cNvPr id="12" name="Rectangle 11"/>
           <p:cNvSpPr/>
           <p:nvPr/>
         </p:nvSpPr>
@@ -22823,7 +22988,7 @@
       </p:sp>
       <p:sp>
         <p:nvSpPr>
-          <p:cNvPr id="12" name="Rectangle 11"/>
+          <p:cNvPr id="13" name="Rectangle 12"/>
           <p:cNvSpPr/>
           <p:nvPr/>
         </p:nvSpPr>
@@ -22867,7 +23032,7 @@
       </p:sp>
       <p:sp>
         <p:nvSpPr>
-          <p:cNvPr id="13" name="TextBox 12"/>
+          <p:cNvPr id="14" name="TextBox 13"/>
           <p:cNvSpPr txBox="1"/>
           <p:nvPr/>
         </p:nvSpPr>
@@ -22906,7 +23071,7 @@
       </p:sp>
       <p:sp>
         <p:nvSpPr>
-          <p:cNvPr id="14" name="TextBox 13"/>
+          <p:cNvPr id="15" name="TextBox 14"/>
           <p:cNvSpPr txBox="1"/>
           <p:nvPr/>
         </p:nvSpPr>
@@ -23005,7 +23170,7 @@
       </p:sp>
       <p:sp>
         <p:nvSpPr>
-          <p:cNvPr id="15" name="Rectangle 14"/>
+          <p:cNvPr id="16" name="Rectangle 15"/>
           <p:cNvSpPr/>
           <p:nvPr/>
         </p:nvSpPr>
@@ -23049,7 +23214,7 @@
       </p:sp>
       <p:sp>
         <p:nvSpPr>
-          <p:cNvPr id="16" name="Rectangle 15"/>
+          <p:cNvPr id="17" name="Rectangle 16"/>
           <p:cNvSpPr/>
           <p:nvPr/>
         </p:nvSpPr>
@@ -23093,7 +23258,7 @@
       </p:sp>
       <p:sp>
         <p:nvSpPr>
-          <p:cNvPr id="17" name="TextBox 16"/>
+          <p:cNvPr id="18" name="TextBox 17"/>
           <p:cNvSpPr txBox="1"/>
           <p:nvPr/>
         </p:nvSpPr>
@@ -23132,7 +23297,7 @@
       </p:sp>
       <p:sp>
         <p:nvSpPr>
-          <p:cNvPr id="18" name="TextBox 17"/>
+          <p:cNvPr id="19" name="TextBox 18"/>
           <p:cNvSpPr txBox="1"/>
           <p:nvPr/>
         </p:nvSpPr>
@@ -23171,7 +23336,7 @@
       </p:sp>
       <p:sp>
         <p:nvSpPr>
-          <p:cNvPr id="19" name="Rectangle 18"/>
+          <p:cNvPr id="20" name="Rectangle 19"/>
           <p:cNvSpPr/>
           <p:nvPr/>
         </p:nvSpPr>
@@ -23215,7 +23380,7 @@
       </p:sp>
       <p:sp>
         <p:nvSpPr>
-          <p:cNvPr id="20" name="Rectangle 19"/>
+          <p:cNvPr id="21" name="Rectangle 20"/>
           <p:cNvSpPr/>
           <p:nvPr/>
         </p:nvSpPr>
@@ -23259,7 +23424,7 @@
       </p:sp>
       <p:sp>
         <p:nvSpPr>
-          <p:cNvPr id="21" name="TextBox 20"/>
+          <p:cNvPr id="22" name="TextBox 21"/>
           <p:cNvSpPr txBox="1"/>
           <p:nvPr/>
         </p:nvSpPr>
@@ -23298,7 +23463,7 @@
       </p:sp>
       <p:sp>
         <p:nvSpPr>
-          <p:cNvPr id="22" name="TextBox 21"/>
+          <p:cNvPr id="23" name="TextBox 22"/>
           <p:cNvSpPr txBox="1"/>
           <p:nvPr/>
         </p:nvSpPr>
@@ -23337,7 +23502,7 @@
       </p:sp>
       <p:sp>
         <p:nvSpPr>
-          <p:cNvPr id="23" name="TextBox 22"/>
+          <p:cNvPr id="24" name="TextBox 23"/>
           <p:cNvSpPr txBox="1"/>
           <p:nvPr/>
         </p:nvSpPr>
@@ -23372,7 +23537,7 @@
       </p:sp>
       <p:sp>
         <p:nvSpPr>
-          <p:cNvPr id="24" name="Rectangle 23"/>
+          <p:cNvPr id="25" name="Rectangle 24"/>
           <p:cNvSpPr/>
           <p:nvPr/>
         </p:nvSpPr>
@@ -23416,7 +23581,7 @@
       </p:sp>
       <p:sp>
         <p:nvSpPr>
-          <p:cNvPr id="25" name="Rectangle 24"/>
+          <p:cNvPr id="26" name="Rectangle 25"/>
           <p:cNvSpPr/>
           <p:nvPr/>
         </p:nvSpPr>
@@ -23460,7 +23625,7 @@
       </p:sp>
       <p:sp>
         <p:nvSpPr>
-          <p:cNvPr id="26" name="TextBox 25"/>
+          <p:cNvPr id="27" name="TextBox 26"/>
           <p:cNvSpPr txBox="1"/>
           <p:nvPr/>
         </p:nvSpPr>
@@ -23499,7 +23664,7 @@
       </p:sp>
       <p:sp>
         <p:nvSpPr>
-          <p:cNvPr id="27" name="TextBox 26"/>
+          <p:cNvPr id="28" name="TextBox 27"/>
           <p:cNvSpPr txBox="1"/>
           <p:nvPr/>
         </p:nvSpPr>
@@ -23780,7 +23945,62 @@
       </p:sp>
       <p:sp>
         <p:nvSpPr>
-          <p:cNvPr id="7" name="Rectangle 6"/>
+          <p:cNvPr id="7" name="Rounded Rectangle 6">
+            <a:hlinkClick action="ppaction://hlinksldjump" r:id="rId3"/>
+          </p:cNvPr>
+          <p:cNvSpPr/>
+          <p:nvPr/>
+        </p:nvSpPr>
+        <p:spPr>
+          <a:xfrm>
+            <a:off x="9128455" y="457200"/>
+            <a:ext cx="2514600" cy="329184"/>
+          </a:xfrm>
+          <a:prstGeom prst="roundRect">
+            <a:avLst/>
+          </a:prstGeom>
+          <a:solidFill>
+            <a:srgbClr val="6B1531"/>
+          </a:solidFill>
+          <a:ln>
+            <a:noFill/>
+          </a:ln>
+          <a:effectLst/>
+        </p:spPr>
+        <p:style>
+          <a:lnRef idx="1">
+            <a:schemeClr val="accent1"/>
+          </a:lnRef>
+          <a:fillRef idx="3">
+            <a:schemeClr val="accent1"/>
+          </a:fillRef>
+          <a:effectRef idx="2">
+            <a:schemeClr val="accent1"/>
+          </a:effectRef>
+          <a:fontRef idx="minor">
+            <a:schemeClr val="lt1"/>
+          </a:fontRef>
+        </p:style>
+        <p:txBody>
+          <a:bodyPr rtlCol="0" anchor="ctr" lIns="0" rIns="0"/>
+          <a:lstStyle/>
+          <a:p>
+            <a:pPr algn="ctr"/>
+            <a:r>
+              <a:rPr sz="1100" b="1">
+                <a:solidFill>
+                  <a:srgbClr val="FFFFFF"/>
+                </a:solidFill>
+                <a:latin typeface="Montserrat"/>
+              </a:rPr>
+              <a:t>&lt; Volver al comparativo</a:t>
+            </a:r>
+          </a:p>
+        </p:txBody>
+      </p:sp>
+      <p:sp>
+        <p:nvSpPr>
+          <p:cNvPr id="8" name="Rectangle 7"/>
           <p:cNvSpPr/>
           <p:nvPr/>
         </p:nvSpPr>
@@ -23824,7 +24044,7 @@
       </p:sp>
       <p:sp>
         <p:nvSpPr>
-          <p:cNvPr id="8" name="Rectangle 7"/>
+          <p:cNvPr id="9" name="Rectangle 8"/>
           <p:cNvSpPr/>
           <p:nvPr/>
         </p:nvSpPr>
@@ -23868,7 +24088,7 @@
       </p:sp>
       <p:sp>
         <p:nvSpPr>
-          <p:cNvPr id="9" name="TextBox 8"/>
+          <p:cNvPr id="10" name="TextBox 9"/>
           <p:cNvSpPr txBox="1"/>
           <p:nvPr/>
         </p:nvSpPr>
@@ -23907,7 +24127,7 @@
       </p:sp>
       <p:sp>
         <p:nvSpPr>
-          <p:cNvPr id="10" name="TextBox 9"/>
+          <p:cNvPr id="11" name="TextBox 10"/>
           <p:cNvSpPr txBox="1"/>
           <p:nvPr/>
         </p:nvSpPr>
@@ -24060,7 +24280,7 @@
       </p:sp>
       <p:sp>
         <p:nvSpPr>
-          <p:cNvPr id="11" name="Rectangle 10"/>
+          <p:cNvPr id="12" name="Rectangle 11"/>
           <p:cNvSpPr/>
           <p:nvPr/>
         </p:nvSpPr>
@@ -24104,7 +24324,7 @@
       </p:sp>
       <p:sp>
         <p:nvSpPr>
-          <p:cNvPr id="12" name="Rectangle 11"/>
+          <p:cNvPr id="13" name="Rectangle 12"/>
           <p:cNvSpPr/>
           <p:nvPr/>
         </p:nvSpPr>
@@ -24148,7 +24368,7 @@
       </p:sp>
       <p:sp>
         <p:nvSpPr>
-          <p:cNvPr id="13" name="TextBox 12"/>
+          <p:cNvPr id="14" name="TextBox 13"/>
           <p:cNvSpPr txBox="1"/>
           <p:nvPr/>
         </p:nvSpPr>
@@ -24187,7 +24407,7 @@
       </p:sp>
       <p:sp>
         <p:nvSpPr>
-          <p:cNvPr id="14" name="TextBox 13"/>
+          <p:cNvPr id="15" name="TextBox 14"/>
           <p:cNvSpPr txBox="1"/>
           <p:nvPr/>
         </p:nvSpPr>
@@ -24340,7 +24560,7 @@
       </p:sp>
       <p:sp>
         <p:nvSpPr>
-          <p:cNvPr id="15" name="TextBox 14"/>
+          <p:cNvPr id="16" name="TextBox 15"/>
           <p:cNvSpPr txBox="1"/>
           <p:nvPr/>
         </p:nvSpPr>
@@ -24375,7 +24595,7 @@
       </p:sp>
       <p:sp>
         <p:nvSpPr>
-          <p:cNvPr id="16" name="Rectangle 15"/>
+          <p:cNvPr id="17" name="Rectangle 16"/>
           <p:cNvSpPr/>
           <p:nvPr/>
         </p:nvSpPr>
@@ -24419,7 +24639,7 @@
       </p:sp>
       <p:sp>
         <p:nvSpPr>
-          <p:cNvPr id="17" name="Rectangle 16"/>
+          <p:cNvPr id="18" name="Rectangle 17"/>
           <p:cNvSpPr/>
           <p:nvPr/>
         </p:nvSpPr>
@@ -24463,7 +24683,7 @@
       </p:sp>
       <p:sp>
         <p:nvSpPr>
-          <p:cNvPr id="18" name="TextBox 17"/>
+          <p:cNvPr id="19" name="TextBox 18"/>
           <p:cNvSpPr txBox="1"/>
           <p:nvPr/>
         </p:nvSpPr>
@@ -24502,7 +24722,7 @@
       </p:sp>
       <p:sp>
         <p:nvSpPr>
-          <p:cNvPr id="19" name="TextBox 18"/>
+          <p:cNvPr id="20" name="TextBox 19"/>
           <p:cNvSpPr txBox="1"/>
           <p:nvPr/>
         </p:nvSpPr>
@@ -24783,7 +25003,62 @@
       </p:sp>
       <p:sp>
         <p:nvSpPr>
-          <p:cNvPr id="7" name="Rectangle 6"/>
+          <p:cNvPr id="7" name="Rounded Rectangle 6">
+            <a:hlinkClick action="ppaction://hlinksldjump" r:id="rId3"/>
+          </p:cNvPr>
+          <p:cNvSpPr/>
+          <p:nvPr/>
+        </p:nvSpPr>
+        <p:spPr>
+          <a:xfrm>
+            <a:off x="9128455" y="457200"/>
+            <a:ext cx="2514600" cy="329184"/>
+          </a:xfrm>
+          <a:prstGeom prst="roundRect">
+            <a:avLst/>
+          </a:prstGeom>
+          <a:solidFill>
+            <a:srgbClr val="6B1531"/>
+          </a:solidFill>
+          <a:ln>
+            <a:noFill/>
+          </a:ln>
+          <a:effectLst/>
+        </p:spPr>
+        <p:style>
+          <a:lnRef idx="1">
+            <a:schemeClr val="accent1"/>
+          </a:lnRef>
+          <a:fillRef idx="3">
+            <a:schemeClr val="accent1"/>
+          </a:fillRef>
+          <a:effectRef idx="2">
+            <a:schemeClr val="accent1"/>
+          </a:effectRef>
+          <a:fontRef idx="minor">
+            <a:schemeClr val="lt1"/>
+          </a:fontRef>
+        </p:style>
+        <p:txBody>
+          <a:bodyPr rtlCol="0" anchor="ctr" lIns="0" rIns="0"/>
+          <a:lstStyle/>
+          <a:p>
+            <a:pPr algn="ctr"/>
+            <a:r>
+              <a:rPr sz="1100" b="1">
+                <a:solidFill>
+                  <a:srgbClr val="FFFFFF"/>
+                </a:solidFill>
+                <a:latin typeface="Montserrat"/>
+              </a:rPr>
+              <a:t>&lt; Volver al comparativo</a:t>
+            </a:r>
+          </a:p>
+        </p:txBody>
+      </p:sp>
+      <p:sp>
+        <p:nvSpPr>
+          <p:cNvPr id="8" name="Rectangle 7"/>
           <p:cNvSpPr/>
           <p:nvPr/>
         </p:nvSpPr>
@@ -24827,7 +25102,7 @@
       </p:sp>
       <p:sp>
         <p:nvSpPr>
-          <p:cNvPr id="8" name="Rectangle 7"/>
+          <p:cNvPr id="9" name="Rectangle 8"/>
           <p:cNvSpPr/>
           <p:nvPr/>
         </p:nvSpPr>
@@ -24871,7 +25146,7 @@
       </p:sp>
       <p:sp>
         <p:nvSpPr>
-          <p:cNvPr id="9" name="TextBox 8"/>
+          <p:cNvPr id="10" name="TextBox 9"/>
           <p:cNvSpPr txBox="1"/>
           <p:nvPr/>
         </p:nvSpPr>
@@ -24910,7 +25185,7 @@
       </p:sp>
       <p:sp>
         <p:nvSpPr>
-          <p:cNvPr id="10" name="TextBox 9"/>
+          <p:cNvPr id="11" name="TextBox 10"/>
           <p:cNvSpPr txBox="1"/>
           <p:nvPr/>
         </p:nvSpPr>
@@ -25009,7 +25284,7 @@
       </p:sp>
       <p:sp>
         <p:nvSpPr>
-          <p:cNvPr id="11" name="Rectangle 10"/>
+          <p:cNvPr id="12" name="Rectangle 11"/>
           <p:cNvSpPr/>
           <p:nvPr/>
         </p:nvSpPr>
@@ -25053,7 +25328,7 @@
       </p:sp>
       <p:sp>
         <p:nvSpPr>
-          <p:cNvPr id="12" name="Rectangle 11"/>
+          <p:cNvPr id="13" name="Rectangle 12"/>
           <p:cNvSpPr/>
           <p:nvPr/>
         </p:nvSpPr>
@@ -25097,7 +25372,7 @@
       </p:sp>
       <p:sp>
         <p:nvSpPr>
-          <p:cNvPr id="13" name="TextBox 12"/>
+          <p:cNvPr id="14" name="TextBox 13"/>
           <p:cNvSpPr txBox="1"/>
           <p:nvPr/>
         </p:nvSpPr>
@@ -25136,7 +25411,7 @@
       </p:sp>
       <p:sp>
         <p:nvSpPr>
-          <p:cNvPr id="14" name="TextBox 13"/>
+          <p:cNvPr id="15" name="TextBox 14"/>
           <p:cNvSpPr txBox="1"/>
           <p:nvPr/>
         </p:nvSpPr>
@@ -25235,7 +25510,7 @@
       </p:sp>
       <p:sp>
         <p:nvSpPr>
-          <p:cNvPr id="15" name="TextBox 14"/>
+          <p:cNvPr id="16" name="TextBox 15"/>
           <p:cNvSpPr txBox="1"/>
           <p:nvPr/>
         </p:nvSpPr>
@@ -25270,7 +25545,7 @@
       </p:sp>
       <p:sp>
         <p:nvSpPr>
-          <p:cNvPr id="16" name="Rectangle 15"/>
+          <p:cNvPr id="17" name="Rectangle 16"/>
           <p:cNvSpPr/>
           <p:nvPr/>
         </p:nvSpPr>
@@ -25314,7 +25589,7 @@
       </p:sp>
       <p:sp>
         <p:nvSpPr>
-          <p:cNvPr id="17" name="Rectangle 16"/>
+          <p:cNvPr id="18" name="Rectangle 17"/>
           <p:cNvSpPr/>
           <p:nvPr/>
         </p:nvSpPr>
@@ -25358,7 +25633,7 @@
       </p:sp>
       <p:sp>
         <p:nvSpPr>
-          <p:cNvPr id="18" name="TextBox 17"/>
+          <p:cNvPr id="19" name="TextBox 18"/>
           <p:cNvSpPr txBox="1"/>
           <p:nvPr/>
         </p:nvSpPr>
@@ -25397,7 +25672,7 @@
       </p:sp>
       <p:sp>
         <p:nvSpPr>
-          <p:cNvPr id="19" name="TextBox 18"/>
+          <p:cNvPr id="20" name="TextBox 19"/>
           <p:cNvSpPr txBox="1"/>
           <p:nvPr/>
         </p:nvSpPr>
@@ -25678,7 +25953,62 @@
       </p:sp>
       <p:sp>
         <p:nvSpPr>
-          <p:cNvPr id="7" name="Rectangle 6"/>
+          <p:cNvPr id="7" name="Rounded Rectangle 6">
+            <a:hlinkClick action="ppaction://hlinksldjump" r:id="rId3"/>
+          </p:cNvPr>
+          <p:cNvSpPr/>
+          <p:nvPr/>
+        </p:nvSpPr>
+        <p:spPr>
+          <a:xfrm>
+            <a:off x="9128455" y="457200"/>
+            <a:ext cx="2514600" cy="329184"/>
+          </a:xfrm>
+          <a:prstGeom prst="roundRect">
+            <a:avLst/>
+          </a:prstGeom>
+          <a:solidFill>
+            <a:srgbClr val="6B1531"/>
+          </a:solidFill>
+          <a:ln>
+            <a:noFill/>
+          </a:ln>
+          <a:effectLst/>
+        </p:spPr>
+        <p:style>
+          <a:lnRef idx="1">
+            <a:schemeClr val="accent1"/>
+          </a:lnRef>
+          <a:fillRef idx="3">
+            <a:schemeClr val="accent1"/>
+          </a:fillRef>
+          <a:effectRef idx="2">
+            <a:schemeClr val="accent1"/>
+          </a:effectRef>
+          <a:fontRef idx="minor">
+            <a:schemeClr val="lt1"/>
+          </a:fontRef>
+        </p:style>
+        <p:txBody>
+          <a:bodyPr rtlCol="0" anchor="ctr" lIns="0" rIns="0"/>
+          <a:lstStyle/>
+          <a:p>
+            <a:pPr algn="ctr"/>
+            <a:r>
+              <a:rPr sz="1100" b="1">
+                <a:solidFill>
+                  <a:srgbClr val="FFFFFF"/>
+                </a:solidFill>
+                <a:latin typeface="Montserrat"/>
+              </a:rPr>
+              <a:t>&lt; Volver al comparativo</a:t>
+            </a:r>
+          </a:p>
+        </p:txBody>
+      </p:sp>
+      <p:sp>
+        <p:nvSpPr>
+          <p:cNvPr id="8" name="Rectangle 7"/>
           <p:cNvSpPr/>
           <p:nvPr/>
         </p:nvSpPr>
@@ -25722,7 +26052,7 @@
       </p:sp>
       <p:sp>
         <p:nvSpPr>
-          <p:cNvPr id="8" name="Rectangle 7"/>
+          <p:cNvPr id="9" name="Rectangle 8"/>
           <p:cNvSpPr/>
           <p:nvPr/>
         </p:nvSpPr>
@@ -25766,7 +26096,7 @@
       </p:sp>
       <p:sp>
         <p:nvSpPr>
-          <p:cNvPr id="9" name="TextBox 8"/>
+          <p:cNvPr id="10" name="TextBox 9"/>
           <p:cNvSpPr txBox="1"/>
           <p:nvPr/>
         </p:nvSpPr>
@@ -25805,7 +26135,7 @@
       </p:sp>
       <p:sp>
         <p:nvSpPr>
-          <p:cNvPr id="10" name="TextBox 9"/>
+          <p:cNvPr id="11" name="TextBox 10"/>
           <p:cNvSpPr txBox="1"/>
           <p:nvPr/>
         </p:nvSpPr>
@@ -25866,7 +26196,7 @@
       </p:sp>
       <p:sp>
         <p:nvSpPr>
-          <p:cNvPr id="11" name="Rectangle 10"/>
+          <p:cNvPr id="12" name="Rectangle 11"/>
           <p:cNvSpPr/>
           <p:nvPr/>
         </p:nvSpPr>
@@ -25910,7 +26240,7 @@
       </p:sp>
       <p:sp>
         <p:nvSpPr>
-          <p:cNvPr id="12" name="Rectangle 11"/>
+          <p:cNvPr id="13" name="Rectangle 12"/>
           <p:cNvSpPr/>
           <p:nvPr/>
         </p:nvSpPr>
@@ -25954,7 +26284,7 @@
       </p:sp>
       <p:sp>
         <p:nvSpPr>
-          <p:cNvPr id="13" name="TextBox 12"/>
+          <p:cNvPr id="14" name="TextBox 13"/>
           <p:cNvSpPr txBox="1"/>
           <p:nvPr/>
         </p:nvSpPr>
@@ -25993,7 +26323,7 @@
       </p:sp>
       <p:sp>
         <p:nvSpPr>
-          <p:cNvPr id="14" name="TextBox 13"/>
+          <p:cNvPr id="15" name="TextBox 14"/>
           <p:cNvSpPr txBox="1"/>
           <p:nvPr/>
         </p:nvSpPr>
@@ -26054,7 +26384,7 @@
       </p:sp>
       <p:sp>
         <p:nvSpPr>
-          <p:cNvPr id="15" name="Rectangle 14"/>
+          <p:cNvPr id="16" name="Rectangle 15"/>
           <p:cNvSpPr/>
           <p:nvPr/>
         </p:nvSpPr>
@@ -26098,7 +26428,7 @@
       </p:sp>
       <p:sp>
         <p:nvSpPr>
-          <p:cNvPr id="16" name="Rectangle 15"/>
+          <p:cNvPr id="17" name="Rectangle 16"/>
           <p:cNvSpPr/>
           <p:nvPr/>
         </p:nvSpPr>
@@ -26142,7 +26472,7 @@
       </p:sp>
       <p:sp>
         <p:nvSpPr>
-          <p:cNvPr id="17" name="TextBox 16"/>
+          <p:cNvPr id="18" name="TextBox 17"/>
           <p:cNvSpPr txBox="1"/>
           <p:nvPr/>
         </p:nvSpPr>
@@ -26181,7 +26511,7 @@
       </p:sp>
       <p:sp>
         <p:nvSpPr>
-          <p:cNvPr id="18" name="TextBox 17"/>
+          <p:cNvPr id="19" name="TextBox 18"/>
           <p:cNvSpPr txBox="1"/>
           <p:nvPr/>
         </p:nvSpPr>
@@ -26220,7 +26550,7 @@
       </p:sp>
       <p:sp>
         <p:nvSpPr>
-          <p:cNvPr id="19" name="Rectangle 18"/>
+          <p:cNvPr id="20" name="Rectangle 19"/>
           <p:cNvSpPr/>
           <p:nvPr/>
         </p:nvSpPr>
@@ -26264,7 +26594,7 @@
       </p:sp>
       <p:sp>
         <p:nvSpPr>
-          <p:cNvPr id="20" name="Rectangle 19"/>
+          <p:cNvPr id="21" name="Rectangle 20"/>
           <p:cNvSpPr/>
           <p:nvPr/>
         </p:nvSpPr>
@@ -26308,7 +26638,7 @@
       </p:sp>
       <p:sp>
         <p:nvSpPr>
-          <p:cNvPr id="21" name="TextBox 20"/>
+          <p:cNvPr id="22" name="TextBox 21"/>
           <p:cNvSpPr txBox="1"/>
           <p:nvPr/>
         </p:nvSpPr>
@@ -26347,7 +26677,7 @@
       </p:sp>
       <p:sp>
         <p:nvSpPr>
-          <p:cNvPr id="22" name="TextBox 21"/>
+          <p:cNvPr id="23" name="TextBox 22"/>
           <p:cNvSpPr txBox="1"/>
           <p:nvPr/>
         </p:nvSpPr>
@@ -26386,7 +26716,7 @@
       </p:sp>
       <p:sp>
         <p:nvSpPr>
-          <p:cNvPr id="23" name="TextBox 22"/>
+          <p:cNvPr id="24" name="TextBox 23"/>
           <p:cNvSpPr txBox="1"/>
           <p:nvPr/>
         </p:nvSpPr>
@@ -26421,7 +26751,7 @@
       </p:sp>
       <p:sp>
         <p:nvSpPr>
-          <p:cNvPr id="24" name="Rectangle 23"/>
+          <p:cNvPr id="25" name="Rectangle 24"/>
           <p:cNvSpPr/>
           <p:nvPr/>
         </p:nvSpPr>
@@ -26465,7 +26795,7 @@
       </p:sp>
       <p:sp>
         <p:nvSpPr>
-          <p:cNvPr id="25" name="Rectangle 24"/>
+          <p:cNvPr id="26" name="Rectangle 25"/>
           <p:cNvSpPr/>
           <p:nvPr/>
         </p:nvSpPr>
@@ -26509,7 +26839,7 @@
       </p:sp>
       <p:sp>
         <p:nvSpPr>
-          <p:cNvPr id="26" name="TextBox 25"/>
+          <p:cNvPr id="27" name="TextBox 26"/>
           <p:cNvSpPr txBox="1"/>
           <p:nvPr/>
         </p:nvSpPr>
@@ -26548,7 +26878,7 @@
       </p:sp>
       <p:sp>
         <p:nvSpPr>
-          <p:cNvPr id="27" name="TextBox 26"/>
+          <p:cNvPr id="28" name="TextBox 27"/>
           <p:cNvSpPr txBox="1"/>
           <p:nvPr/>
         </p:nvSpPr>
@@ -26829,7 +27159,62 @@
       </p:sp>
       <p:sp>
         <p:nvSpPr>
-          <p:cNvPr id="7" name="Rectangle 6"/>
+          <p:cNvPr id="7" name="Rounded Rectangle 6">
+            <a:hlinkClick action="ppaction://hlinksldjump" r:id="rId3"/>
+          </p:cNvPr>
+          <p:cNvSpPr/>
+          <p:nvPr/>
+        </p:nvSpPr>
+        <p:spPr>
+          <a:xfrm>
+            <a:off x="9128455" y="457200"/>
+            <a:ext cx="2514600" cy="329184"/>
+          </a:xfrm>
+          <a:prstGeom prst="roundRect">
+            <a:avLst/>
+          </a:prstGeom>
+          <a:solidFill>
+            <a:srgbClr val="6B1531"/>
+          </a:solidFill>
+          <a:ln>
+            <a:noFill/>
+          </a:ln>
+          <a:effectLst/>
+        </p:spPr>
+        <p:style>
+          <a:lnRef idx="1">
+            <a:schemeClr val="accent1"/>
+          </a:lnRef>
+          <a:fillRef idx="3">
+            <a:schemeClr val="accent1"/>
+          </a:fillRef>
+          <a:effectRef idx="2">
+            <a:schemeClr val="accent1"/>
+          </a:effectRef>
+          <a:fontRef idx="minor">
+            <a:schemeClr val="lt1"/>
+          </a:fontRef>
+        </p:style>
+        <p:txBody>
+          <a:bodyPr rtlCol="0" anchor="ctr" lIns="0" rIns="0"/>
+          <a:lstStyle/>
+          <a:p>
+            <a:pPr algn="ctr"/>
+            <a:r>
+              <a:rPr sz="1100" b="1">
+                <a:solidFill>
+                  <a:srgbClr val="FFFFFF"/>
+                </a:solidFill>
+                <a:latin typeface="Montserrat"/>
+              </a:rPr>
+              <a:t>&lt; Volver al comparativo</a:t>
+            </a:r>
+          </a:p>
+        </p:txBody>
+      </p:sp>
+      <p:sp>
+        <p:nvSpPr>
+          <p:cNvPr id="8" name="Rectangle 7"/>
           <p:cNvSpPr/>
           <p:nvPr/>
         </p:nvSpPr>
@@ -26873,7 +27258,7 @@
       </p:sp>
       <p:sp>
         <p:nvSpPr>
-          <p:cNvPr id="8" name="Rectangle 7"/>
+          <p:cNvPr id="9" name="Rectangle 8"/>
           <p:cNvSpPr/>
           <p:nvPr/>
         </p:nvSpPr>
@@ -26917,7 +27302,7 @@
       </p:sp>
       <p:sp>
         <p:nvSpPr>
-          <p:cNvPr id="9" name="TextBox 8"/>
+          <p:cNvPr id="10" name="TextBox 9"/>
           <p:cNvSpPr txBox="1"/>
           <p:nvPr/>
         </p:nvSpPr>
@@ -26956,7 +27341,7 @@
       </p:sp>
       <p:sp>
         <p:nvSpPr>
-          <p:cNvPr id="10" name="TextBox 9"/>
+          <p:cNvPr id="11" name="TextBox 10"/>
           <p:cNvSpPr txBox="1"/>
           <p:nvPr/>
         </p:nvSpPr>
@@ -27054,7 +27439,7 @@
       </p:sp>
       <p:sp>
         <p:nvSpPr>
-          <p:cNvPr id="11" name="Rectangle 10"/>
+          <p:cNvPr id="12" name="Rectangle 11"/>
           <p:cNvSpPr/>
           <p:nvPr/>
         </p:nvSpPr>
@@ -27098,7 +27483,7 @@
       </p:sp>
       <p:sp>
         <p:nvSpPr>
-          <p:cNvPr id="12" name="Rectangle 11"/>
+          <p:cNvPr id="13" name="Rectangle 12"/>
           <p:cNvSpPr/>
           <p:nvPr/>
         </p:nvSpPr>
@@ -27142,7 +27527,7 @@
       </p:sp>
       <p:sp>
         <p:nvSpPr>
-          <p:cNvPr id="13" name="TextBox 12"/>
+          <p:cNvPr id="14" name="TextBox 13"/>
           <p:cNvSpPr txBox="1"/>
           <p:nvPr/>
         </p:nvSpPr>
@@ -27181,7 +27566,7 @@
       </p:sp>
       <p:sp>
         <p:nvSpPr>
-          <p:cNvPr id="14" name="TextBox 13"/>
+          <p:cNvPr id="15" name="TextBox 14"/>
           <p:cNvSpPr txBox="1"/>
           <p:nvPr/>
         </p:nvSpPr>
@@ -27279,7 +27664,7 @@
       </p:sp>
       <p:sp>
         <p:nvSpPr>
-          <p:cNvPr id="15" name="TextBox 14"/>
+          <p:cNvPr id="16" name="TextBox 15"/>
           <p:cNvSpPr txBox="1"/>
           <p:nvPr/>
         </p:nvSpPr>
@@ -27314,7 +27699,7 @@
       </p:sp>
       <p:sp>
         <p:nvSpPr>
-          <p:cNvPr id="16" name="Rectangle 15"/>
+          <p:cNvPr id="17" name="Rectangle 16"/>
           <p:cNvSpPr/>
           <p:nvPr/>
         </p:nvSpPr>
@@ -27358,7 +27743,7 @@
       </p:sp>
       <p:sp>
         <p:nvSpPr>
-          <p:cNvPr id="17" name="Rectangle 16"/>
+          <p:cNvPr id="18" name="Rectangle 17"/>
           <p:cNvSpPr/>
           <p:nvPr/>
         </p:nvSpPr>
@@ -27402,7 +27787,7 @@
       </p:sp>
       <p:sp>
         <p:nvSpPr>
-          <p:cNvPr id="18" name="TextBox 17"/>
+          <p:cNvPr id="19" name="TextBox 18"/>
           <p:cNvSpPr txBox="1"/>
           <p:nvPr/>
         </p:nvSpPr>
@@ -27441,7 +27826,7 @@
       </p:sp>
       <p:sp>
         <p:nvSpPr>
-          <p:cNvPr id="19" name="TextBox 18"/>
+          <p:cNvPr id="20" name="TextBox 19"/>
           <p:cNvSpPr txBox="1"/>
           <p:nvPr/>
         </p:nvSpPr>
@@ -27722,7 +28107,62 @@
       </p:sp>
       <p:sp>
         <p:nvSpPr>
-          <p:cNvPr id="7" name="Rectangle 6"/>
+          <p:cNvPr id="7" name="Rounded Rectangle 6">
+            <a:hlinkClick action="ppaction://hlinksldjump" r:id="rId3"/>
+          </p:cNvPr>
+          <p:cNvSpPr/>
+          <p:nvPr/>
+        </p:nvSpPr>
+        <p:spPr>
+          <a:xfrm>
+            <a:off x="9128455" y="457200"/>
+            <a:ext cx="2514600" cy="329184"/>
+          </a:xfrm>
+          <a:prstGeom prst="roundRect">
+            <a:avLst/>
+          </a:prstGeom>
+          <a:solidFill>
+            <a:srgbClr val="6B1531"/>
+          </a:solidFill>
+          <a:ln>
+            <a:noFill/>
+          </a:ln>
+          <a:effectLst/>
+        </p:spPr>
+        <p:style>
+          <a:lnRef idx="1">
+            <a:schemeClr val="accent1"/>
+          </a:lnRef>
+          <a:fillRef idx="3">
+            <a:schemeClr val="accent1"/>
+          </a:fillRef>
+          <a:effectRef idx="2">
+            <a:schemeClr val="accent1"/>
+          </a:effectRef>
+          <a:fontRef idx="minor">
+            <a:schemeClr val="lt1"/>
+          </a:fontRef>
+        </p:style>
+        <p:txBody>
+          <a:bodyPr rtlCol="0" anchor="ctr" lIns="0" rIns="0"/>
+          <a:lstStyle/>
+          <a:p>
+            <a:pPr algn="ctr"/>
+            <a:r>
+              <a:rPr sz="1100" b="1">
+                <a:solidFill>
+                  <a:srgbClr val="FFFFFF"/>
+                </a:solidFill>
+                <a:latin typeface="Montserrat"/>
+              </a:rPr>
+              <a:t>&lt; Volver al comparativo</a:t>
+            </a:r>
+          </a:p>
+        </p:txBody>
+      </p:sp>
+      <p:sp>
+        <p:nvSpPr>
+          <p:cNvPr id="8" name="Rectangle 7"/>
           <p:cNvSpPr/>
           <p:nvPr/>
         </p:nvSpPr>
@@ -27766,7 +28206,7 @@
       </p:sp>
       <p:sp>
         <p:nvSpPr>
-          <p:cNvPr id="8" name="Rectangle 7"/>
+          <p:cNvPr id="9" name="Rectangle 8"/>
           <p:cNvSpPr/>
           <p:nvPr/>
         </p:nvSpPr>
@@ -27810,7 +28250,7 @@
       </p:sp>
       <p:sp>
         <p:nvSpPr>
-          <p:cNvPr id="9" name="TextBox 8"/>
+          <p:cNvPr id="10" name="TextBox 9"/>
           <p:cNvSpPr txBox="1"/>
           <p:nvPr/>
         </p:nvSpPr>
@@ -27849,7 +28289,7 @@
       </p:sp>
       <p:sp>
         <p:nvSpPr>
-          <p:cNvPr id="10" name="TextBox 9"/>
+          <p:cNvPr id="11" name="TextBox 10"/>
           <p:cNvSpPr txBox="1"/>
           <p:nvPr/>
         </p:nvSpPr>
@@ -27910,7 +28350,7 @@
       </p:sp>
       <p:sp>
         <p:nvSpPr>
-          <p:cNvPr id="11" name="Rectangle 10"/>
+          <p:cNvPr id="12" name="Rectangle 11"/>
           <p:cNvSpPr/>
           <p:nvPr/>
         </p:nvSpPr>
@@ -27954,7 +28394,7 @@
       </p:sp>
       <p:sp>
         <p:nvSpPr>
-          <p:cNvPr id="12" name="Rectangle 11"/>
+          <p:cNvPr id="13" name="Rectangle 12"/>
           <p:cNvSpPr/>
           <p:nvPr/>
         </p:nvSpPr>
@@ -27998,7 +28438,7 @@
       </p:sp>
       <p:sp>
         <p:nvSpPr>
-          <p:cNvPr id="13" name="TextBox 12"/>
+          <p:cNvPr id="14" name="TextBox 13"/>
           <p:cNvSpPr txBox="1"/>
           <p:nvPr/>
         </p:nvSpPr>
@@ -28037,7 +28477,7 @@
       </p:sp>
       <p:sp>
         <p:nvSpPr>
-          <p:cNvPr id="14" name="TextBox 13"/>
+          <p:cNvPr id="15" name="TextBox 14"/>
           <p:cNvSpPr txBox="1"/>
           <p:nvPr/>
         </p:nvSpPr>
@@ -28116,7 +28556,7 @@
       </p:sp>
       <p:sp>
         <p:nvSpPr>
-          <p:cNvPr id="15" name="TextBox 14"/>
+          <p:cNvPr id="16" name="TextBox 15"/>
           <p:cNvSpPr txBox="1"/>
           <p:nvPr/>
         </p:nvSpPr>
@@ -28151,7 +28591,7 @@
       </p:sp>
       <p:sp>
         <p:nvSpPr>
-          <p:cNvPr id="16" name="Rectangle 15"/>
+          <p:cNvPr id="17" name="Rectangle 16"/>
           <p:cNvSpPr/>
           <p:nvPr/>
         </p:nvSpPr>
@@ -28195,7 +28635,7 @@
       </p:sp>
       <p:sp>
         <p:nvSpPr>
-          <p:cNvPr id="17" name="Rectangle 16"/>
+          <p:cNvPr id="18" name="Rectangle 17"/>
           <p:cNvSpPr/>
           <p:nvPr/>
         </p:nvSpPr>
@@ -28239,7 +28679,7 @@
       </p:sp>
       <p:sp>
         <p:nvSpPr>
-          <p:cNvPr id="18" name="TextBox 17"/>
+          <p:cNvPr id="19" name="TextBox 18"/>
           <p:cNvSpPr txBox="1"/>
           <p:nvPr/>
         </p:nvSpPr>
@@ -28278,7 +28718,7 @@
       </p:sp>
       <p:sp>
         <p:nvSpPr>
-          <p:cNvPr id="19" name="TextBox 18"/>
+          <p:cNvPr id="20" name="TextBox 19"/>
           <p:cNvSpPr txBox="1"/>
           <p:nvPr/>
         </p:nvSpPr>
@@ -28559,7 +28999,62 @@
       </p:sp>
       <p:sp>
         <p:nvSpPr>
-          <p:cNvPr id="7" name="Rectangle 6"/>
+          <p:cNvPr id="7" name="Rounded Rectangle 6">
+            <a:hlinkClick action="ppaction://hlinksldjump" r:id="rId3"/>
+          </p:cNvPr>
+          <p:cNvSpPr/>
+          <p:nvPr/>
+        </p:nvSpPr>
+        <p:spPr>
+          <a:xfrm>
+            <a:off x="9128455" y="457200"/>
+            <a:ext cx="2514600" cy="329184"/>
+          </a:xfrm>
+          <a:prstGeom prst="roundRect">
+            <a:avLst/>
+          </a:prstGeom>
+          <a:solidFill>
+            <a:srgbClr val="6B1531"/>
+          </a:solidFill>
+          <a:ln>
+            <a:noFill/>
+          </a:ln>
+          <a:effectLst/>
+        </p:spPr>
+        <p:style>
+          <a:lnRef idx="1">
+            <a:schemeClr val="accent1"/>
+          </a:lnRef>
+          <a:fillRef idx="3">
+            <a:schemeClr val="accent1"/>
+          </a:fillRef>
+          <a:effectRef idx="2">
+            <a:schemeClr val="accent1"/>
+          </a:effectRef>
+          <a:fontRef idx="minor">
+            <a:schemeClr val="lt1"/>
+          </a:fontRef>
+        </p:style>
+        <p:txBody>
+          <a:bodyPr rtlCol="0" anchor="ctr" lIns="0" rIns="0"/>
+          <a:lstStyle/>
+          <a:p>
+            <a:pPr algn="ctr"/>
+            <a:r>
+              <a:rPr sz="1100" b="1">
+                <a:solidFill>
+                  <a:srgbClr val="FFFFFF"/>
+                </a:solidFill>
+                <a:latin typeface="Montserrat"/>
+              </a:rPr>
+              <a:t>&lt; Volver al comparativo</a:t>
+            </a:r>
+          </a:p>
+        </p:txBody>
+      </p:sp>
+      <p:sp>
+        <p:nvSpPr>
+          <p:cNvPr id="8" name="Rectangle 7"/>
           <p:cNvSpPr/>
           <p:nvPr/>
         </p:nvSpPr>
@@ -28603,7 +29098,7 @@
       </p:sp>
       <p:sp>
         <p:nvSpPr>
-          <p:cNvPr id="8" name="Rectangle 7"/>
+          <p:cNvPr id="9" name="Rectangle 8"/>
           <p:cNvSpPr/>
           <p:nvPr/>
         </p:nvSpPr>
@@ -28647,7 +29142,7 @@
       </p:sp>
       <p:sp>
         <p:nvSpPr>
-          <p:cNvPr id="9" name="TextBox 8"/>
+          <p:cNvPr id="10" name="TextBox 9"/>
           <p:cNvSpPr txBox="1"/>
           <p:nvPr/>
         </p:nvSpPr>
@@ -28686,7 +29181,7 @@
       </p:sp>
       <p:sp>
         <p:nvSpPr>
-          <p:cNvPr id="10" name="TextBox 9"/>
+          <p:cNvPr id="11" name="TextBox 10"/>
           <p:cNvSpPr txBox="1"/>
           <p:nvPr/>
         </p:nvSpPr>
@@ -28819,7 +29314,7 @@
       </p:sp>
       <p:sp>
         <p:nvSpPr>
-          <p:cNvPr id="11" name="Rectangle 10"/>
+          <p:cNvPr id="12" name="Rectangle 11"/>
           <p:cNvSpPr/>
           <p:nvPr/>
         </p:nvSpPr>
@@ -28863,7 +29358,7 @@
       </p:sp>
       <p:sp>
         <p:nvSpPr>
-          <p:cNvPr id="12" name="Rectangle 11"/>
+          <p:cNvPr id="13" name="Rectangle 12"/>
           <p:cNvSpPr/>
           <p:nvPr/>
         </p:nvSpPr>
@@ -28907,7 +29402,7 @@
       </p:sp>
       <p:sp>
         <p:nvSpPr>
-          <p:cNvPr id="13" name="TextBox 12"/>
+          <p:cNvPr id="14" name="TextBox 13"/>
           <p:cNvSpPr txBox="1"/>
           <p:nvPr/>
         </p:nvSpPr>
@@ -28946,7 +29441,7 @@
       </p:sp>
       <p:sp>
         <p:nvSpPr>
-          <p:cNvPr id="14" name="TextBox 13"/>
+          <p:cNvPr id="15" name="TextBox 14"/>
           <p:cNvSpPr txBox="1"/>
           <p:nvPr/>
         </p:nvSpPr>
@@ -29070,7 +29565,7 @@
       </p:sp>
       <p:sp>
         <p:nvSpPr>
-          <p:cNvPr id="15" name="TextBox 14"/>
+          <p:cNvPr id="16" name="TextBox 15"/>
           <p:cNvSpPr txBox="1"/>
           <p:nvPr/>
         </p:nvSpPr>
@@ -29105,7 +29600,7 @@
       </p:sp>
       <p:sp>
         <p:nvSpPr>
-          <p:cNvPr id="16" name="Rectangle 15"/>
+          <p:cNvPr id="17" name="Rectangle 16"/>
           <p:cNvSpPr/>
           <p:nvPr/>
         </p:nvSpPr>
@@ -29149,7 +29644,7 @@
       </p:sp>
       <p:sp>
         <p:nvSpPr>
-          <p:cNvPr id="17" name="Rectangle 16"/>
+          <p:cNvPr id="18" name="Rectangle 17"/>
           <p:cNvSpPr/>
           <p:nvPr/>
         </p:nvSpPr>
@@ -29193,7 +29688,7 @@
       </p:sp>
       <p:sp>
         <p:nvSpPr>
-          <p:cNvPr id="18" name="TextBox 17"/>
+          <p:cNvPr id="19" name="TextBox 18"/>
           <p:cNvSpPr txBox="1"/>
           <p:nvPr/>
         </p:nvSpPr>
@@ -29232,7 +29727,7 @@
       </p:sp>
       <p:sp>
         <p:nvSpPr>
-          <p:cNvPr id="19" name="TextBox 18"/>
+          <p:cNvPr id="20" name="TextBox 19"/>
           <p:cNvSpPr txBox="1"/>
           <p:nvPr/>
         </p:nvSpPr>
@@ -30849,7 +31344,62 @@
       </p:sp>
       <p:sp>
         <p:nvSpPr>
-          <p:cNvPr id="7" name="Rectangle 6"/>
+          <p:cNvPr id="7" name="Rounded Rectangle 6">
+            <a:hlinkClick action="ppaction://hlinksldjump" r:id="rId3"/>
+          </p:cNvPr>
+          <p:cNvSpPr/>
+          <p:nvPr/>
+        </p:nvSpPr>
+        <p:spPr>
+          <a:xfrm>
+            <a:off x="9128455" y="457200"/>
+            <a:ext cx="2514600" cy="329184"/>
+          </a:xfrm>
+          <a:prstGeom prst="roundRect">
+            <a:avLst/>
+          </a:prstGeom>
+          <a:solidFill>
+            <a:srgbClr val="6B1531"/>
+          </a:solidFill>
+          <a:ln>
+            <a:noFill/>
+          </a:ln>
+          <a:effectLst/>
+        </p:spPr>
+        <p:style>
+          <a:lnRef idx="1">
+            <a:schemeClr val="accent1"/>
+          </a:lnRef>
+          <a:fillRef idx="3">
+            <a:schemeClr val="accent1"/>
+          </a:fillRef>
+          <a:effectRef idx="2">
+            <a:schemeClr val="accent1"/>
+          </a:effectRef>
+          <a:fontRef idx="minor">
+            <a:schemeClr val="lt1"/>
+          </a:fontRef>
+        </p:style>
+        <p:txBody>
+          <a:bodyPr rtlCol="0" anchor="ctr" lIns="0" rIns="0"/>
+          <a:lstStyle/>
+          <a:p>
+            <a:pPr algn="ctr"/>
+            <a:r>
+              <a:rPr sz="1100" b="1">
+                <a:solidFill>
+                  <a:srgbClr val="FFFFFF"/>
+                </a:solidFill>
+                <a:latin typeface="Montserrat"/>
+              </a:rPr>
+              <a:t>&lt; Volver al comparativo</a:t>
+            </a:r>
+          </a:p>
+        </p:txBody>
+      </p:sp>
+      <p:sp>
+        <p:nvSpPr>
+          <p:cNvPr id="8" name="Rectangle 7"/>
           <p:cNvSpPr/>
           <p:nvPr/>
         </p:nvSpPr>
@@ -30893,7 +31443,7 @@
       </p:sp>
       <p:sp>
         <p:nvSpPr>
-          <p:cNvPr id="8" name="Rectangle 7"/>
+          <p:cNvPr id="9" name="Rectangle 8"/>
           <p:cNvSpPr/>
           <p:nvPr/>
         </p:nvSpPr>
@@ -30937,7 +31487,7 @@
       </p:sp>
       <p:sp>
         <p:nvSpPr>
-          <p:cNvPr id="9" name="TextBox 8"/>
+          <p:cNvPr id="10" name="TextBox 9"/>
           <p:cNvSpPr txBox="1"/>
           <p:nvPr/>
         </p:nvSpPr>
@@ -30976,7 +31526,7 @@
       </p:sp>
       <p:sp>
         <p:nvSpPr>
-          <p:cNvPr id="10" name="TextBox 9"/>
+          <p:cNvPr id="11" name="TextBox 10"/>
           <p:cNvSpPr txBox="1"/>
           <p:nvPr/>
         </p:nvSpPr>
@@ -31109,7 +31659,7 @@
       </p:sp>
       <p:sp>
         <p:nvSpPr>
-          <p:cNvPr id="11" name="Rectangle 10"/>
+          <p:cNvPr id="12" name="Rectangle 11"/>
           <p:cNvSpPr/>
           <p:nvPr/>
         </p:nvSpPr>
@@ -31153,7 +31703,7 @@
       </p:sp>
       <p:sp>
         <p:nvSpPr>
-          <p:cNvPr id="12" name="Rectangle 11"/>
+          <p:cNvPr id="13" name="Rectangle 12"/>
           <p:cNvSpPr/>
           <p:nvPr/>
         </p:nvSpPr>
@@ -31197,7 +31747,7 @@
       </p:sp>
       <p:sp>
         <p:nvSpPr>
-          <p:cNvPr id="13" name="TextBox 12"/>
+          <p:cNvPr id="14" name="TextBox 13"/>
           <p:cNvSpPr txBox="1"/>
           <p:nvPr/>
         </p:nvSpPr>
@@ -31236,7 +31786,7 @@
       </p:sp>
       <p:sp>
         <p:nvSpPr>
-          <p:cNvPr id="14" name="TextBox 13"/>
+          <p:cNvPr id="15" name="TextBox 14"/>
           <p:cNvSpPr txBox="1"/>
           <p:nvPr/>
         </p:nvSpPr>
@@ -31315,7 +31865,7 @@
       </p:sp>
       <p:sp>
         <p:nvSpPr>
-          <p:cNvPr id="15" name="TextBox 14"/>
+          <p:cNvPr id="16" name="TextBox 15"/>
           <p:cNvSpPr txBox="1"/>
           <p:nvPr/>
         </p:nvSpPr>
@@ -31350,7 +31900,7 @@
       </p:sp>
       <p:sp>
         <p:nvSpPr>
-          <p:cNvPr id="16" name="Rectangle 15"/>
+          <p:cNvPr id="17" name="Rectangle 16"/>
           <p:cNvSpPr/>
           <p:nvPr/>
         </p:nvSpPr>
@@ -31394,7 +31944,7 @@
       </p:sp>
       <p:sp>
         <p:nvSpPr>
-          <p:cNvPr id="17" name="Rectangle 16"/>
+          <p:cNvPr id="18" name="Rectangle 17"/>
           <p:cNvSpPr/>
           <p:nvPr/>
         </p:nvSpPr>
@@ -31438,7 +31988,7 @@
       </p:sp>
       <p:sp>
         <p:nvSpPr>
-          <p:cNvPr id="18" name="TextBox 17"/>
+          <p:cNvPr id="19" name="TextBox 18"/>
           <p:cNvSpPr txBox="1"/>
           <p:nvPr/>
         </p:nvSpPr>
@@ -31477,7 +32027,7 @@
       </p:sp>
       <p:sp>
         <p:nvSpPr>
-          <p:cNvPr id="19" name="TextBox 18"/>
+          <p:cNvPr id="20" name="TextBox 19"/>
           <p:cNvSpPr txBox="1"/>
           <p:nvPr/>
         </p:nvSpPr>
@@ -31758,7 +32308,62 @@
       </p:sp>
       <p:sp>
         <p:nvSpPr>
-          <p:cNvPr id="7" name="Rectangle 6"/>
+          <p:cNvPr id="7" name="Rounded Rectangle 6">
+            <a:hlinkClick action="ppaction://hlinksldjump" r:id="rId3"/>
+          </p:cNvPr>
+          <p:cNvSpPr/>
+          <p:nvPr/>
+        </p:nvSpPr>
+        <p:spPr>
+          <a:xfrm>
+            <a:off x="9128455" y="457200"/>
+            <a:ext cx="2514600" cy="329184"/>
+          </a:xfrm>
+          <a:prstGeom prst="roundRect">
+            <a:avLst/>
+          </a:prstGeom>
+          <a:solidFill>
+            <a:srgbClr val="6B1531"/>
+          </a:solidFill>
+          <a:ln>
+            <a:noFill/>
+          </a:ln>
+          <a:effectLst/>
+        </p:spPr>
+        <p:style>
+          <a:lnRef idx="1">
+            <a:schemeClr val="accent1"/>
+          </a:lnRef>
+          <a:fillRef idx="3">
+            <a:schemeClr val="accent1"/>
+          </a:fillRef>
+          <a:effectRef idx="2">
+            <a:schemeClr val="accent1"/>
+          </a:effectRef>
+          <a:fontRef idx="minor">
+            <a:schemeClr val="lt1"/>
+          </a:fontRef>
+        </p:style>
+        <p:txBody>
+          <a:bodyPr rtlCol="0" anchor="ctr" lIns="0" rIns="0"/>
+          <a:lstStyle/>
+          <a:p>
+            <a:pPr algn="ctr"/>
+            <a:r>
+              <a:rPr sz="1100" b="1">
+                <a:solidFill>
+                  <a:srgbClr val="FFFFFF"/>
+                </a:solidFill>
+                <a:latin typeface="Montserrat"/>
+              </a:rPr>
+              <a:t>&lt; Volver al comparativo</a:t>
+            </a:r>
+          </a:p>
+        </p:txBody>
+      </p:sp>
+      <p:sp>
+        <p:nvSpPr>
+          <p:cNvPr id="8" name="Rectangle 7"/>
           <p:cNvSpPr/>
           <p:nvPr/>
         </p:nvSpPr>
@@ -31802,7 +32407,7 @@
       </p:sp>
       <p:sp>
         <p:nvSpPr>
-          <p:cNvPr id="8" name="Rectangle 7"/>
+          <p:cNvPr id="9" name="Rectangle 8"/>
           <p:cNvSpPr/>
           <p:nvPr/>
         </p:nvSpPr>
@@ -31846,7 +32451,7 @@
       </p:sp>
       <p:sp>
         <p:nvSpPr>
-          <p:cNvPr id="9" name="TextBox 8"/>
+          <p:cNvPr id="10" name="TextBox 9"/>
           <p:cNvSpPr txBox="1"/>
           <p:nvPr/>
         </p:nvSpPr>
@@ -31885,7 +32490,7 @@
       </p:sp>
       <p:sp>
         <p:nvSpPr>
-          <p:cNvPr id="10" name="TextBox 9"/>
+          <p:cNvPr id="11" name="TextBox 10"/>
           <p:cNvSpPr txBox="1"/>
           <p:nvPr/>
         </p:nvSpPr>
@@ -31964,7 +32569,7 @@
       </p:sp>
       <p:sp>
         <p:nvSpPr>
-          <p:cNvPr id="11" name="Rectangle 10"/>
+          <p:cNvPr id="12" name="Rectangle 11"/>
           <p:cNvSpPr/>
           <p:nvPr/>
         </p:nvSpPr>
@@ -32008,7 +32613,7 @@
       </p:sp>
       <p:sp>
         <p:nvSpPr>
-          <p:cNvPr id="12" name="Rectangle 11"/>
+          <p:cNvPr id="13" name="Rectangle 12"/>
           <p:cNvSpPr/>
           <p:nvPr/>
         </p:nvSpPr>
@@ -32052,7 +32657,7 @@
       </p:sp>
       <p:sp>
         <p:nvSpPr>
-          <p:cNvPr id="13" name="TextBox 12"/>
+          <p:cNvPr id="14" name="TextBox 13"/>
           <p:cNvSpPr txBox="1"/>
           <p:nvPr/>
         </p:nvSpPr>
@@ -32091,7 +32696,7 @@
       </p:sp>
       <p:sp>
         <p:nvSpPr>
-          <p:cNvPr id="14" name="TextBox 13"/>
+          <p:cNvPr id="15" name="TextBox 14"/>
           <p:cNvSpPr txBox="1"/>
           <p:nvPr/>
         </p:nvSpPr>
@@ -32179,7 +32784,7 @@
       </p:sp>
       <p:sp>
         <p:nvSpPr>
-          <p:cNvPr id="15" name="TextBox 14"/>
+          <p:cNvPr id="16" name="TextBox 15"/>
           <p:cNvSpPr txBox="1"/>
           <p:nvPr/>
         </p:nvSpPr>
@@ -32214,7 +32819,7 @@
       </p:sp>
       <p:sp>
         <p:nvSpPr>
-          <p:cNvPr id="16" name="Rectangle 15"/>
+          <p:cNvPr id="17" name="Rectangle 16"/>
           <p:cNvSpPr/>
           <p:nvPr/>
         </p:nvSpPr>
@@ -32258,7 +32863,7 @@
       </p:sp>
       <p:sp>
         <p:nvSpPr>
-          <p:cNvPr id="17" name="Rectangle 16"/>
+          <p:cNvPr id="18" name="Rectangle 17"/>
           <p:cNvSpPr/>
           <p:nvPr/>
         </p:nvSpPr>
@@ -32302,7 +32907,7 @@
       </p:sp>
       <p:sp>
         <p:nvSpPr>
-          <p:cNvPr id="18" name="TextBox 17"/>
+          <p:cNvPr id="19" name="TextBox 18"/>
           <p:cNvSpPr txBox="1"/>
           <p:nvPr/>
         </p:nvSpPr>
@@ -32341,7 +32946,7 @@
       </p:sp>
       <p:sp>
         <p:nvSpPr>
-          <p:cNvPr id="19" name="TextBox 18"/>
+          <p:cNvPr id="20" name="TextBox 19"/>
           <p:cNvSpPr txBox="1"/>
           <p:nvPr/>
         </p:nvSpPr>
@@ -32622,7 +33227,62 @@
       </p:sp>
       <p:sp>
         <p:nvSpPr>
-          <p:cNvPr id="7" name="Rectangle 6"/>
+          <p:cNvPr id="7" name="Rounded Rectangle 6">
+            <a:hlinkClick action="ppaction://hlinksldjump" r:id="rId3"/>
+          </p:cNvPr>
+          <p:cNvSpPr/>
+          <p:nvPr/>
+        </p:nvSpPr>
+        <p:spPr>
+          <a:xfrm>
+            <a:off x="9128455" y="457200"/>
+            <a:ext cx="2514600" cy="329184"/>
+          </a:xfrm>
+          <a:prstGeom prst="roundRect">
+            <a:avLst/>
+          </a:prstGeom>
+          <a:solidFill>
+            <a:srgbClr val="6B1531"/>
+          </a:solidFill>
+          <a:ln>
+            <a:noFill/>
+          </a:ln>
+          <a:effectLst/>
+        </p:spPr>
+        <p:style>
+          <a:lnRef idx="1">
+            <a:schemeClr val="accent1"/>
+          </a:lnRef>
+          <a:fillRef idx="3">
+            <a:schemeClr val="accent1"/>
+          </a:fillRef>
+          <a:effectRef idx="2">
+            <a:schemeClr val="accent1"/>
+          </a:effectRef>
+          <a:fontRef idx="minor">
+            <a:schemeClr val="lt1"/>
+          </a:fontRef>
+        </p:style>
+        <p:txBody>
+          <a:bodyPr rtlCol="0" anchor="ctr" lIns="0" rIns="0"/>
+          <a:lstStyle/>
+          <a:p>
+            <a:pPr algn="ctr"/>
+            <a:r>
+              <a:rPr sz="1100" b="1">
+                <a:solidFill>
+                  <a:srgbClr val="FFFFFF"/>
+                </a:solidFill>
+                <a:latin typeface="Montserrat"/>
+              </a:rPr>
+              <a:t>&lt; Volver al comparativo</a:t>
+            </a:r>
+          </a:p>
+        </p:txBody>
+      </p:sp>
+      <p:sp>
+        <p:nvSpPr>
+          <p:cNvPr id="8" name="Rectangle 7"/>
           <p:cNvSpPr/>
           <p:nvPr/>
         </p:nvSpPr>
@@ -32666,7 +33326,7 @@
       </p:sp>
       <p:sp>
         <p:nvSpPr>
-          <p:cNvPr id="8" name="Rectangle 7"/>
+          <p:cNvPr id="9" name="Rectangle 8"/>
           <p:cNvSpPr/>
           <p:nvPr/>
         </p:nvSpPr>
@@ -32710,7 +33370,7 @@
       </p:sp>
       <p:sp>
         <p:nvSpPr>
-          <p:cNvPr id="9" name="TextBox 8"/>
+          <p:cNvPr id="10" name="TextBox 9"/>
           <p:cNvSpPr txBox="1"/>
           <p:nvPr/>
         </p:nvSpPr>
@@ -32749,7 +33409,7 @@
       </p:sp>
       <p:sp>
         <p:nvSpPr>
-          <p:cNvPr id="10" name="TextBox 9"/>
+          <p:cNvPr id="11" name="TextBox 10"/>
           <p:cNvSpPr txBox="1"/>
           <p:nvPr/>
         </p:nvSpPr>
@@ -32829,7 +33489,7 @@
       </p:sp>
       <p:sp>
         <p:nvSpPr>
-          <p:cNvPr id="11" name="Rectangle 10"/>
+          <p:cNvPr id="12" name="Rectangle 11"/>
           <p:cNvSpPr/>
           <p:nvPr/>
         </p:nvSpPr>
@@ -32873,7 +33533,7 @@
       </p:sp>
       <p:sp>
         <p:nvSpPr>
-          <p:cNvPr id="12" name="Rectangle 11"/>
+          <p:cNvPr id="13" name="Rectangle 12"/>
           <p:cNvSpPr/>
           <p:nvPr/>
         </p:nvSpPr>
@@ -32917,7 +33577,7 @@
       </p:sp>
       <p:sp>
         <p:nvSpPr>
-          <p:cNvPr id="13" name="TextBox 12"/>
+          <p:cNvPr id="14" name="TextBox 13"/>
           <p:cNvSpPr txBox="1"/>
           <p:nvPr/>
         </p:nvSpPr>
@@ -32956,7 +33616,7 @@
       </p:sp>
       <p:sp>
         <p:nvSpPr>
-          <p:cNvPr id="14" name="TextBox 13"/>
+          <p:cNvPr id="15" name="TextBox 14"/>
           <p:cNvSpPr txBox="1"/>
           <p:nvPr/>
         </p:nvSpPr>
@@ -33036,7 +33696,7 @@
       </p:sp>
       <p:sp>
         <p:nvSpPr>
-          <p:cNvPr id="15" name="Rectangle 14"/>
+          <p:cNvPr id="16" name="Rectangle 15"/>
           <p:cNvSpPr/>
           <p:nvPr/>
         </p:nvSpPr>
@@ -33080,7 +33740,7 @@
       </p:sp>
       <p:sp>
         <p:nvSpPr>
-          <p:cNvPr id="16" name="Rectangle 15"/>
+          <p:cNvPr id="17" name="Rectangle 16"/>
           <p:cNvSpPr/>
           <p:nvPr/>
         </p:nvSpPr>
@@ -33124,7 +33784,7 @@
       </p:sp>
       <p:sp>
         <p:nvSpPr>
-          <p:cNvPr id="17" name="TextBox 16"/>
+          <p:cNvPr id="18" name="TextBox 17"/>
           <p:cNvSpPr txBox="1"/>
           <p:nvPr/>
         </p:nvSpPr>
@@ -33163,7 +33823,7 @@
       </p:sp>
       <p:sp>
         <p:nvSpPr>
-          <p:cNvPr id="18" name="TextBox 17"/>
+          <p:cNvPr id="19" name="TextBox 18"/>
           <p:cNvSpPr txBox="1"/>
           <p:nvPr/>
         </p:nvSpPr>
@@ -33202,7 +33862,7 @@
       </p:sp>
       <p:sp>
         <p:nvSpPr>
-          <p:cNvPr id="19" name="Rectangle 18"/>
+          <p:cNvPr id="20" name="Rectangle 19"/>
           <p:cNvSpPr/>
           <p:nvPr/>
         </p:nvSpPr>
@@ -33246,7 +33906,7 @@
       </p:sp>
       <p:sp>
         <p:nvSpPr>
-          <p:cNvPr id="20" name="Rectangle 19"/>
+          <p:cNvPr id="21" name="Rectangle 20"/>
           <p:cNvSpPr/>
           <p:nvPr/>
         </p:nvSpPr>
@@ -33290,7 +33950,7 @@
       </p:sp>
       <p:sp>
         <p:nvSpPr>
-          <p:cNvPr id="21" name="TextBox 20"/>
+          <p:cNvPr id="22" name="TextBox 21"/>
           <p:cNvSpPr txBox="1"/>
           <p:nvPr/>
         </p:nvSpPr>
@@ -33329,7 +33989,7 @@
       </p:sp>
       <p:sp>
         <p:nvSpPr>
-          <p:cNvPr id="22" name="TextBox 21"/>
+          <p:cNvPr id="23" name="TextBox 22"/>
           <p:cNvSpPr txBox="1"/>
           <p:nvPr/>
         </p:nvSpPr>
@@ -33368,7 +34028,7 @@
       </p:sp>
       <p:sp>
         <p:nvSpPr>
-          <p:cNvPr id="23" name="TextBox 22"/>
+          <p:cNvPr id="24" name="TextBox 23"/>
           <p:cNvSpPr txBox="1"/>
           <p:nvPr/>
         </p:nvSpPr>
@@ -33403,7 +34063,7 @@
       </p:sp>
       <p:sp>
         <p:nvSpPr>
-          <p:cNvPr id="24" name="Rectangle 23"/>
+          <p:cNvPr id="25" name="Rectangle 24"/>
           <p:cNvSpPr/>
           <p:nvPr/>
         </p:nvSpPr>
@@ -33447,7 +34107,7 @@
       </p:sp>
       <p:sp>
         <p:nvSpPr>
-          <p:cNvPr id="25" name="Rectangle 24"/>
+          <p:cNvPr id="26" name="Rectangle 25"/>
           <p:cNvSpPr/>
           <p:nvPr/>
         </p:nvSpPr>
@@ -33491,7 +34151,7 @@
       </p:sp>
       <p:sp>
         <p:nvSpPr>
-          <p:cNvPr id="26" name="TextBox 25"/>
+          <p:cNvPr id="27" name="TextBox 26"/>
           <p:cNvSpPr txBox="1"/>
           <p:nvPr/>
         </p:nvSpPr>
@@ -33530,7 +34190,7 @@
       </p:sp>
       <p:sp>
         <p:nvSpPr>
-          <p:cNvPr id="27" name="TextBox 26"/>
+          <p:cNvPr id="28" name="TextBox 27"/>
           <p:cNvSpPr txBox="1"/>
           <p:nvPr/>
         </p:nvSpPr>
@@ -33811,7 +34471,62 @@
       </p:sp>
       <p:sp>
         <p:nvSpPr>
-          <p:cNvPr id="7" name="Rectangle 6"/>
+          <p:cNvPr id="7" name="Rounded Rectangle 6">
+            <a:hlinkClick action="ppaction://hlinksldjump" r:id="rId3"/>
+          </p:cNvPr>
+          <p:cNvSpPr/>
+          <p:nvPr/>
+        </p:nvSpPr>
+        <p:spPr>
+          <a:xfrm>
+            <a:off x="9128455" y="457200"/>
+            <a:ext cx="2514600" cy="329184"/>
+          </a:xfrm>
+          <a:prstGeom prst="roundRect">
+            <a:avLst/>
+          </a:prstGeom>
+          <a:solidFill>
+            <a:srgbClr val="6B1531"/>
+          </a:solidFill>
+          <a:ln>
+            <a:noFill/>
+          </a:ln>
+          <a:effectLst/>
+        </p:spPr>
+        <p:style>
+          <a:lnRef idx="1">
+            <a:schemeClr val="accent1"/>
+          </a:lnRef>
+          <a:fillRef idx="3">
+            <a:schemeClr val="accent1"/>
+          </a:fillRef>
+          <a:effectRef idx="2">
+            <a:schemeClr val="accent1"/>
+          </a:effectRef>
+          <a:fontRef idx="minor">
+            <a:schemeClr val="lt1"/>
+          </a:fontRef>
+        </p:style>
+        <p:txBody>
+          <a:bodyPr rtlCol="0" anchor="ctr" lIns="0" rIns="0"/>
+          <a:lstStyle/>
+          <a:p>
+            <a:pPr algn="ctr"/>
+            <a:r>
+              <a:rPr sz="1100" b="1">
+                <a:solidFill>
+                  <a:srgbClr val="FFFFFF"/>
+                </a:solidFill>
+                <a:latin typeface="Montserrat"/>
+              </a:rPr>
+              <a:t>&lt; Volver al comparativo</a:t>
+            </a:r>
+          </a:p>
+        </p:txBody>
+      </p:sp>
+      <p:sp>
+        <p:nvSpPr>
+          <p:cNvPr id="8" name="Rectangle 7"/>
           <p:cNvSpPr/>
           <p:nvPr/>
         </p:nvSpPr>
@@ -33855,7 +34570,7 @@
       </p:sp>
       <p:sp>
         <p:nvSpPr>
-          <p:cNvPr id="8" name="Rectangle 7"/>
+          <p:cNvPr id="9" name="Rectangle 8"/>
           <p:cNvSpPr/>
           <p:nvPr/>
         </p:nvSpPr>
@@ -33899,7 +34614,7 @@
       </p:sp>
       <p:sp>
         <p:nvSpPr>
-          <p:cNvPr id="9" name="TextBox 8"/>
+          <p:cNvPr id="10" name="TextBox 9"/>
           <p:cNvSpPr txBox="1"/>
           <p:nvPr/>
         </p:nvSpPr>
@@ -33938,7 +34653,7 @@
       </p:sp>
       <p:sp>
         <p:nvSpPr>
-          <p:cNvPr id="10" name="TextBox 9"/>
+          <p:cNvPr id="11" name="TextBox 10"/>
           <p:cNvSpPr txBox="1"/>
           <p:nvPr/>
         </p:nvSpPr>
@@ -34017,7 +34732,7 @@
       </p:sp>
       <p:sp>
         <p:nvSpPr>
-          <p:cNvPr id="11" name="Rectangle 10"/>
+          <p:cNvPr id="12" name="Rectangle 11"/>
           <p:cNvSpPr/>
           <p:nvPr/>
         </p:nvSpPr>
@@ -34061,7 +34776,7 @@
       </p:sp>
       <p:sp>
         <p:nvSpPr>
-          <p:cNvPr id="12" name="Rectangle 11"/>
+          <p:cNvPr id="13" name="Rectangle 12"/>
           <p:cNvSpPr/>
           <p:nvPr/>
         </p:nvSpPr>
@@ -34105,7 +34820,7 @@
       </p:sp>
       <p:sp>
         <p:nvSpPr>
-          <p:cNvPr id="13" name="TextBox 12"/>
+          <p:cNvPr id="14" name="TextBox 13"/>
           <p:cNvSpPr txBox="1"/>
           <p:nvPr/>
         </p:nvSpPr>
@@ -34144,7 +34859,7 @@
       </p:sp>
       <p:sp>
         <p:nvSpPr>
-          <p:cNvPr id="14" name="TextBox 13"/>
+          <p:cNvPr id="15" name="TextBox 14"/>
           <p:cNvSpPr txBox="1"/>
           <p:nvPr/>
         </p:nvSpPr>
@@ -34232,7 +34947,7 @@
       </p:sp>
       <p:sp>
         <p:nvSpPr>
-          <p:cNvPr id="15" name="TextBox 14"/>
+          <p:cNvPr id="16" name="TextBox 15"/>
           <p:cNvSpPr txBox="1"/>
           <p:nvPr/>
         </p:nvSpPr>
@@ -34267,7 +34982,7 @@
       </p:sp>
       <p:sp>
         <p:nvSpPr>
-          <p:cNvPr id="16" name="Rectangle 15"/>
+          <p:cNvPr id="17" name="Rectangle 16"/>
           <p:cNvSpPr/>
           <p:nvPr/>
         </p:nvSpPr>
@@ -34311,7 +35026,7 @@
       </p:sp>
       <p:sp>
         <p:nvSpPr>
-          <p:cNvPr id="17" name="Rectangle 16"/>
+          <p:cNvPr id="18" name="Rectangle 17"/>
           <p:cNvSpPr/>
           <p:nvPr/>
         </p:nvSpPr>
@@ -34355,7 +35070,7 @@
       </p:sp>
       <p:sp>
         <p:nvSpPr>
-          <p:cNvPr id="18" name="TextBox 17"/>
+          <p:cNvPr id="19" name="TextBox 18"/>
           <p:cNvSpPr txBox="1"/>
           <p:nvPr/>
         </p:nvSpPr>
@@ -34394,7 +35109,7 @@
       </p:sp>
       <p:sp>
         <p:nvSpPr>
-          <p:cNvPr id="19" name="TextBox 18"/>
+          <p:cNvPr id="20" name="TextBox 19"/>
           <p:cNvSpPr txBox="1"/>
           <p:nvPr/>
         </p:nvSpPr>
@@ -34675,7 +35390,62 @@
       </p:sp>
       <p:sp>
         <p:nvSpPr>
-          <p:cNvPr id="7" name="Rectangle 6"/>
+          <p:cNvPr id="7" name="Rounded Rectangle 6">
+            <a:hlinkClick action="ppaction://hlinksldjump" r:id="rId3"/>
+          </p:cNvPr>
+          <p:cNvSpPr/>
+          <p:nvPr/>
+        </p:nvSpPr>
+        <p:spPr>
+          <a:xfrm>
+            <a:off x="9128455" y="457200"/>
+            <a:ext cx="2514600" cy="329184"/>
+          </a:xfrm>
+          <a:prstGeom prst="roundRect">
+            <a:avLst/>
+          </a:prstGeom>
+          <a:solidFill>
+            <a:srgbClr val="6B1531"/>
+          </a:solidFill>
+          <a:ln>
+            <a:noFill/>
+          </a:ln>
+          <a:effectLst/>
+        </p:spPr>
+        <p:style>
+          <a:lnRef idx="1">
+            <a:schemeClr val="accent1"/>
+          </a:lnRef>
+          <a:fillRef idx="3">
+            <a:schemeClr val="accent1"/>
+          </a:fillRef>
+          <a:effectRef idx="2">
+            <a:schemeClr val="accent1"/>
+          </a:effectRef>
+          <a:fontRef idx="minor">
+            <a:schemeClr val="lt1"/>
+          </a:fontRef>
+        </p:style>
+        <p:txBody>
+          <a:bodyPr rtlCol="0" anchor="ctr" lIns="0" rIns="0"/>
+          <a:lstStyle/>
+          <a:p>
+            <a:pPr algn="ctr"/>
+            <a:r>
+              <a:rPr sz="1100" b="1">
+                <a:solidFill>
+                  <a:srgbClr val="FFFFFF"/>
+                </a:solidFill>
+                <a:latin typeface="Montserrat"/>
+              </a:rPr>
+              <a:t>&lt; Volver al comparativo</a:t>
+            </a:r>
+          </a:p>
+        </p:txBody>
+      </p:sp>
+      <p:sp>
+        <p:nvSpPr>
+          <p:cNvPr id="8" name="Rectangle 7"/>
           <p:cNvSpPr/>
           <p:nvPr/>
         </p:nvSpPr>
@@ -34719,7 +35489,7 @@
       </p:sp>
       <p:sp>
         <p:nvSpPr>
-          <p:cNvPr id="8" name="Rectangle 7"/>
+          <p:cNvPr id="9" name="Rectangle 8"/>
           <p:cNvSpPr/>
           <p:nvPr/>
         </p:nvSpPr>
@@ -34763,7 +35533,7 @@
       </p:sp>
       <p:sp>
         <p:nvSpPr>
-          <p:cNvPr id="9" name="TextBox 8"/>
+          <p:cNvPr id="10" name="TextBox 9"/>
           <p:cNvSpPr txBox="1"/>
           <p:nvPr/>
         </p:nvSpPr>
@@ -34802,7 +35572,7 @@
       </p:sp>
       <p:sp>
         <p:nvSpPr>
-          <p:cNvPr id="10" name="TextBox 9"/>
+          <p:cNvPr id="11" name="TextBox 10"/>
           <p:cNvSpPr txBox="1"/>
           <p:nvPr/>
         </p:nvSpPr>
@@ -34863,7 +35633,7 @@
       </p:sp>
       <p:sp>
         <p:nvSpPr>
-          <p:cNvPr id="11" name="Rectangle 10"/>
+          <p:cNvPr id="12" name="Rectangle 11"/>
           <p:cNvSpPr/>
           <p:nvPr/>
         </p:nvSpPr>
@@ -34907,7 +35677,7 @@
       </p:sp>
       <p:sp>
         <p:nvSpPr>
-          <p:cNvPr id="12" name="Rectangle 11"/>
+          <p:cNvPr id="13" name="Rectangle 12"/>
           <p:cNvSpPr/>
           <p:nvPr/>
         </p:nvSpPr>
@@ -34951,7 +35721,7 @@
       </p:sp>
       <p:sp>
         <p:nvSpPr>
-          <p:cNvPr id="13" name="TextBox 12"/>
+          <p:cNvPr id="14" name="TextBox 13"/>
           <p:cNvSpPr txBox="1"/>
           <p:nvPr/>
         </p:nvSpPr>
@@ -34990,7 +35760,7 @@
       </p:sp>
       <p:sp>
         <p:nvSpPr>
-          <p:cNvPr id="14" name="TextBox 13"/>
+          <p:cNvPr id="15" name="TextBox 14"/>
           <p:cNvSpPr txBox="1"/>
           <p:nvPr/>
         </p:nvSpPr>
@@ -35069,7 +35839,7 @@
       </p:sp>
       <p:sp>
         <p:nvSpPr>
-          <p:cNvPr id="15" name="Rectangle 14"/>
+          <p:cNvPr id="16" name="Rectangle 15"/>
           <p:cNvSpPr/>
           <p:nvPr/>
         </p:nvSpPr>
@@ -35113,7 +35883,7 @@
       </p:sp>
       <p:sp>
         <p:nvSpPr>
-          <p:cNvPr id="16" name="Rectangle 15"/>
+          <p:cNvPr id="17" name="Rectangle 16"/>
           <p:cNvSpPr/>
           <p:nvPr/>
         </p:nvSpPr>
@@ -35157,7 +35927,7 @@
       </p:sp>
       <p:sp>
         <p:nvSpPr>
-          <p:cNvPr id="17" name="TextBox 16"/>
+          <p:cNvPr id="18" name="TextBox 17"/>
           <p:cNvSpPr txBox="1"/>
           <p:nvPr/>
         </p:nvSpPr>
@@ -35196,7 +35966,7 @@
       </p:sp>
       <p:sp>
         <p:nvSpPr>
-          <p:cNvPr id="18" name="TextBox 17"/>
+          <p:cNvPr id="19" name="TextBox 18"/>
           <p:cNvSpPr txBox="1"/>
           <p:nvPr/>
         </p:nvSpPr>
@@ -35235,7 +36005,7 @@
       </p:sp>
       <p:sp>
         <p:nvSpPr>
-          <p:cNvPr id="19" name="Rectangle 18"/>
+          <p:cNvPr id="20" name="Rectangle 19"/>
           <p:cNvSpPr/>
           <p:nvPr/>
         </p:nvSpPr>
@@ -35279,7 +36049,7 @@
       </p:sp>
       <p:sp>
         <p:nvSpPr>
-          <p:cNvPr id="20" name="Rectangle 19"/>
+          <p:cNvPr id="21" name="Rectangle 20"/>
           <p:cNvSpPr/>
           <p:nvPr/>
         </p:nvSpPr>
@@ -35323,7 +36093,7 @@
       </p:sp>
       <p:sp>
         <p:nvSpPr>
-          <p:cNvPr id="21" name="TextBox 20"/>
+          <p:cNvPr id="22" name="TextBox 21"/>
           <p:cNvSpPr txBox="1"/>
           <p:nvPr/>
         </p:nvSpPr>
@@ -35362,7 +36132,7 @@
       </p:sp>
       <p:sp>
         <p:nvSpPr>
-          <p:cNvPr id="22" name="TextBox 21"/>
+          <p:cNvPr id="23" name="TextBox 22"/>
           <p:cNvSpPr txBox="1"/>
           <p:nvPr/>
         </p:nvSpPr>
@@ -35401,7 +36171,7 @@
       </p:sp>
       <p:sp>
         <p:nvSpPr>
-          <p:cNvPr id="23" name="TextBox 22"/>
+          <p:cNvPr id="24" name="TextBox 23"/>
           <p:cNvSpPr txBox="1"/>
           <p:nvPr/>
         </p:nvSpPr>
@@ -35436,7 +36206,7 @@
       </p:sp>
       <p:sp>
         <p:nvSpPr>
-          <p:cNvPr id="24" name="Rectangle 23"/>
+          <p:cNvPr id="25" name="Rectangle 24"/>
           <p:cNvSpPr/>
           <p:nvPr/>
         </p:nvSpPr>
@@ -35480,7 +36250,7 @@
       </p:sp>
       <p:sp>
         <p:nvSpPr>
-          <p:cNvPr id="25" name="Rectangle 24"/>
+          <p:cNvPr id="26" name="Rectangle 25"/>
           <p:cNvSpPr/>
           <p:nvPr/>
         </p:nvSpPr>
@@ -35524,7 +36294,7 @@
       </p:sp>
       <p:sp>
         <p:nvSpPr>
-          <p:cNvPr id="26" name="TextBox 25"/>
+          <p:cNvPr id="27" name="TextBox 26"/>
           <p:cNvSpPr txBox="1"/>
           <p:nvPr/>
         </p:nvSpPr>
@@ -35563,7 +36333,7 @@
       </p:sp>
       <p:sp>
         <p:nvSpPr>
-          <p:cNvPr id="27" name="TextBox 26"/>
+          <p:cNvPr id="28" name="TextBox 27"/>
           <p:cNvSpPr txBox="1"/>
           <p:nvPr/>
         </p:nvSpPr>
@@ -35844,7 +36614,62 @@
       </p:sp>
       <p:sp>
         <p:nvSpPr>
-          <p:cNvPr id="7" name="Rectangle 6"/>
+          <p:cNvPr id="7" name="Rounded Rectangle 6">
+            <a:hlinkClick action="ppaction://hlinksldjump" r:id="rId3"/>
+          </p:cNvPr>
+          <p:cNvSpPr/>
+          <p:nvPr/>
+        </p:nvSpPr>
+        <p:spPr>
+          <a:xfrm>
+            <a:off x="9128455" y="457200"/>
+            <a:ext cx="2514600" cy="329184"/>
+          </a:xfrm>
+          <a:prstGeom prst="roundRect">
+            <a:avLst/>
+          </a:prstGeom>
+          <a:solidFill>
+            <a:srgbClr val="6B1531"/>
+          </a:solidFill>
+          <a:ln>
+            <a:noFill/>
+          </a:ln>
+          <a:effectLst/>
+        </p:spPr>
+        <p:style>
+          <a:lnRef idx="1">
+            <a:schemeClr val="accent1"/>
+          </a:lnRef>
+          <a:fillRef idx="3">
+            <a:schemeClr val="accent1"/>
+          </a:fillRef>
+          <a:effectRef idx="2">
+            <a:schemeClr val="accent1"/>
+          </a:effectRef>
+          <a:fontRef idx="minor">
+            <a:schemeClr val="lt1"/>
+          </a:fontRef>
+        </p:style>
+        <p:txBody>
+          <a:bodyPr rtlCol="0" anchor="ctr" lIns="0" rIns="0"/>
+          <a:lstStyle/>
+          <a:p>
+            <a:pPr algn="ctr"/>
+            <a:r>
+              <a:rPr sz="1100" b="1">
+                <a:solidFill>
+                  <a:srgbClr val="FFFFFF"/>
+                </a:solidFill>
+                <a:latin typeface="Montserrat"/>
+              </a:rPr>
+              <a:t>&lt; Volver al comparativo</a:t>
+            </a:r>
+          </a:p>
+        </p:txBody>
+      </p:sp>
+      <p:sp>
+        <p:nvSpPr>
+          <p:cNvPr id="8" name="Rectangle 7"/>
           <p:cNvSpPr/>
           <p:nvPr/>
         </p:nvSpPr>
@@ -35888,7 +36713,7 @@
       </p:sp>
       <p:sp>
         <p:nvSpPr>
-          <p:cNvPr id="8" name="Rectangle 7"/>
+          <p:cNvPr id="9" name="Rectangle 8"/>
           <p:cNvSpPr/>
           <p:nvPr/>
         </p:nvSpPr>
@@ -35932,7 +36757,7 @@
       </p:sp>
       <p:sp>
         <p:nvSpPr>
-          <p:cNvPr id="9" name="TextBox 8"/>
+          <p:cNvPr id="10" name="TextBox 9"/>
           <p:cNvSpPr txBox="1"/>
           <p:nvPr/>
         </p:nvSpPr>
@@ -35971,7 +36796,7 @@
       </p:sp>
       <p:sp>
         <p:nvSpPr>
-          <p:cNvPr id="10" name="TextBox 9"/>
+          <p:cNvPr id="11" name="TextBox 10"/>
           <p:cNvSpPr txBox="1"/>
           <p:nvPr/>
         </p:nvSpPr>
@@ -36070,7 +36895,7 @@
       </p:sp>
       <p:sp>
         <p:nvSpPr>
-          <p:cNvPr id="11" name="Rectangle 10"/>
+          <p:cNvPr id="12" name="Rectangle 11"/>
           <p:cNvSpPr/>
           <p:nvPr/>
         </p:nvSpPr>
@@ -36114,7 +36939,7 @@
       </p:sp>
       <p:sp>
         <p:nvSpPr>
-          <p:cNvPr id="12" name="Rectangle 11"/>
+          <p:cNvPr id="13" name="Rectangle 12"/>
           <p:cNvSpPr/>
           <p:nvPr/>
         </p:nvSpPr>
@@ -36158,7 +36983,7 @@
       </p:sp>
       <p:sp>
         <p:nvSpPr>
-          <p:cNvPr id="13" name="TextBox 12"/>
+          <p:cNvPr id="14" name="TextBox 13"/>
           <p:cNvSpPr txBox="1"/>
           <p:nvPr/>
         </p:nvSpPr>
@@ -36197,7 +37022,7 @@
       </p:sp>
       <p:sp>
         <p:nvSpPr>
-          <p:cNvPr id="14" name="TextBox 13"/>
+          <p:cNvPr id="15" name="TextBox 14"/>
           <p:cNvSpPr txBox="1"/>
           <p:nvPr/>
         </p:nvSpPr>
@@ -36296,7 +37121,7 @@
       </p:sp>
       <p:sp>
         <p:nvSpPr>
-          <p:cNvPr id="15" name="TextBox 14"/>
+          <p:cNvPr id="16" name="TextBox 15"/>
           <p:cNvSpPr txBox="1"/>
           <p:nvPr/>
         </p:nvSpPr>
@@ -36331,7 +37156,7 @@
       </p:sp>
       <p:sp>
         <p:nvSpPr>
-          <p:cNvPr id="16" name="Rectangle 15"/>
+          <p:cNvPr id="17" name="Rectangle 16"/>
           <p:cNvSpPr/>
           <p:nvPr/>
         </p:nvSpPr>
@@ -36375,7 +37200,7 @@
       </p:sp>
       <p:sp>
         <p:nvSpPr>
-          <p:cNvPr id="17" name="Rectangle 16"/>
+          <p:cNvPr id="18" name="Rectangle 17"/>
           <p:cNvSpPr/>
           <p:nvPr/>
         </p:nvSpPr>
@@ -36419,7 +37244,7 @@
       </p:sp>
       <p:sp>
         <p:nvSpPr>
-          <p:cNvPr id="18" name="TextBox 17"/>
+          <p:cNvPr id="19" name="TextBox 18"/>
           <p:cNvSpPr txBox="1"/>
           <p:nvPr/>
         </p:nvSpPr>
@@ -36458,7 +37283,7 @@
       </p:sp>
       <p:sp>
         <p:nvSpPr>
-          <p:cNvPr id="19" name="TextBox 18"/>
+          <p:cNvPr id="20" name="TextBox 19"/>
           <p:cNvSpPr txBox="1"/>
           <p:nvPr/>
         </p:nvSpPr>
@@ -36739,7 +37564,62 @@
       </p:sp>
       <p:sp>
         <p:nvSpPr>
-          <p:cNvPr id="7" name="Rectangle 6"/>
+          <p:cNvPr id="7" name="Rounded Rectangle 6">
+            <a:hlinkClick action="ppaction://hlinksldjump" r:id="rId3"/>
+          </p:cNvPr>
+          <p:cNvSpPr/>
+          <p:nvPr/>
+        </p:nvSpPr>
+        <p:spPr>
+          <a:xfrm>
+            <a:off x="9128455" y="457200"/>
+            <a:ext cx="2514600" cy="329184"/>
+          </a:xfrm>
+          <a:prstGeom prst="roundRect">
+            <a:avLst/>
+          </a:prstGeom>
+          <a:solidFill>
+            <a:srgbClr val="6B1531"/>
+          </a:solidFill>
+          <a:ln>
+            <a:noFill/>
+          </a:ln>
+          <a:effectLst/>
+        </p:spPr>
+        <p:style>
+          <a:lnRef idx="1">
+            <a:schemeClr val="accent1"/>
+          </a:lnRef>
+          <a:fillRef idx="3">
+            <a:schemeClr val="accent1"/>
+          </a:fillRef>
+          <a:effectRef idx="2">
+            <a:schemeClr val="accent1"/>
+          </a:effectRef>
+          <a:fontRef idx="minor">
+            <a:schemeClr val="lt1"/>
+          </a:fontRef>
+        </p:style>
+        <p:txBody>
+          <a:bodyPr rtlCol="0" anchor="ctr" lIns="0" rIns="0"/>
+          <a:lstStyle/>
+          <a:p>
+            <a:pPr algn="ctr"/>
+            <a:r>
+              <a:rPr sz="1100" b="1">
+                <a:solidFill>
+                  <a:srgbClr val="FFFFFF"/>
+                </a:solidFill>
+                <a:latin typeface="Montserrat"/>
+              </a:rPr>
+              <a:t>&lt; Volver al comparativo</a:t>
+            </a:r>
+          </a:p>
+        </p:txBody>
+      </p:sp>
+      <p:sp>
+        <p:nvSpPr>
+          <p:cNvPr id="8" name="Rectangle 7"/>
           <p:cNvSpPr/>
           <p:nvPr/>
         </p:nvSpPr>
@@ -36783,7 +37663,7 @@
       </p:sp>
       <p:sp>
         <p:nvSpPr>
-          <p:cNvPr id="8" name="Rectangle 7"/>
+          <p:cNvPr id="9" name="Rectangle 8"/>
           <p:cNvSpPr/>
           <p:nvPr/>
         </p:nvSpPr>
@@ -36827,7 +37707,7 @@
       </p:sp>
       <p:sp>
         <p:nvSpPr>
-          <p:cNvPr id="9" name="TextBox 8"/>
+          <p:cNvPr id="10" name="TextBox 9"/>
           <p:cNvSpPr txBox="1"/>
           <p:nvPr/>
         </p:nvSpPr>
@@ -36866,7 +37746,7 @@
       </p:sp>
       <p:sp>
         <p:nvSpPr>
-          <p:cNvPr id="10" name="TextBox 9"/>
+          <p:cNvPr id="11" name="TextBox 10"/>
           <p:cNvSpPr txBox="1"/>
           <p:nvPr/>
         </p:nvSpPr>
@@ -36965,7 +37845,7 @@
       </p:sp>
       <p:sp>
         <p:nvSpPr>
-          <p:cNvPr id="11" name="Rectangle 10"/>
+          <p:cNvPr id="12" name="Rectangle 11"/>
           <p:cNvSpPr/>
           <p:nvPr/>
         </p:nvSpPr>
@@ -37009,7 +37889,7 @@
       </p:sp>
       <p:sp>
         <p:nvSpPr>
-          <p:cNvPr id="12" name="Rectangle 11"/>
+          <p:cNvPr id="13" name="Rectangle 12"/>
           <p:cNvSpPr/>
           <p:nvPr/>
         </p:nvSpPr>
@@ -37053,7 +37933,7 @@
       </p:sp>
       <p:sp>
         <p:nvSpPr>
-          <p:cNvPr id="13" name="TextBox 12"/>
+          <p:cNvPr id="14" name="TextBox 13"/>
           <p:cNvSpPr txBox="1"/>
           <p:nvPr/>
         </p:nvSpPr>
@@ -37092,7 +37972,7 @@
       </p:sp>
       <p:sp>
         <p:nvSpPr>
-          <p:cNvPr id="14" name="TextBox 13"/>
+          <p:cNvPr id="15" name="TextBox 14"/>
           <p:cNvSpPr txBox="1"/>
           <p:nvPr/>
         </p:nvSpPr>
@@ -37191,7 +38071,7 @@
       </p:sp>
       <p:sp>
         <p:nvSpPr>
-          <p:cNvPr id="15" name="TextBox 14"/>
+          <p:cNvPr id="16" name="TextBox 15"/>
           <p:cNvSpPr txBox="1"/>
           <p:nvPr/>
         </p:nvSpPr>
@@ -37226,7 +38106,7 @@
       </p:sp>
       <p:sp>
         <p:nvSpPr>
-          <p:cNvPr id="16" name="Rectangle 15"/>
+          <p:cNvPr id="17" name="Rectangle 16"/>
           <p:cNvSpPr/>
           <p:nvPr/>
         </p:nvSpPr>
@@ -37270,7 +38150,7 @@
       </p:sp>
       <p:sp>
         <p:nvSpPr>
-          <p:cNvPr id="17" name="Rectangle 16"/>
+          <p:cNvPr id="18" name="Rectangle 17"/>
           <p:cNvSpPr/>
           <p:nvPr/>
         </p:nvSpPr>
@@ -37314,7 +38194,7 @@
       </p:sp>
       <p:sp>
         <p:nvSpPr>
-          <p:cNvPr id="18" name="TextBox 17"/>
+          <p:cNvPr id="19" name="TextBox 18"/>
           <p:cNvSpPr txBox="1"/>
           <p:nvPr/>
         </p:nvSpPr>
@@ -37353,7 +38233,7 @@
       </p:sp>
       <p:sp>
         <p:nvSpPr>
-          <p:cNvPr id="19" name="TextBox 18"/>
+          <p:cNvPr id="20" name="TextBox 19"/>
           <p:cNvSpPr txBox="1"/>
           <p:nvPr/>
         </p:nvSpPr>
@@ -37634,7 +38514,62 @@
       </p:sp>
       <p:sp>
         <p:nvSpPr>
-          <p:cNvPr id="7" name="Rectangle 6"/>
+          <p:cNvPr id="7" name="Rounded Rectangle 6">
+            <a:hlinkClick action="ppaction://hlinksldjump" r:id="rId3"/>
+          </p:cNvPr>
+          <p:cNvSpPr/>
+          <p:nvPr/>
+        </p:nvSpPr>
+        <p:spPr>
+          <a:xfrm>
+            <a:off x="9128455" y="457200"/>
+            <a:ext cx="2514600" cy="329184"/>
+          </a:xfrm>
+          <a:prstGeom prst="roundRect">
+            <a:avLst/>
+          </a:prstGeom>
+          <a:solidFill>
+            <a:srgbClr val="6B1531"/>
+          </a:solidFill>
+          <a:ln>
+            <a:noFill/>
+          </a:ln>
+          <a:effectLst/>
+        </p:spPr>
+        <p:style>
+          <a:lnRef idx="1">
+            <a:schemeClr val="accent1"/>
+          </a:lnRef>
+          <a:fillRef idx="3">
+            <a:schemeClr val="accent1"/>
+          </a:fillRef>
+          <a:effectRef idx="2">
+            <a:schemeClr val="accent1"/>
+          </a:effectRef>
+          <a:fontRef idx="minor">
+            <a:schemeClr val="lt1"/>
+          </a:fontRef>
+        </p:style>
+        <p:txBody>
+          <a:bodyPr rtlCol="0" anchor="ctr" lIns="0" rIns="0"/>
+          <a:lstStyle/>
+          <a:p>
+            <a:pPr algn="ctr"/>
+            <a:r>
+              <a:rPr sz="1100" b="1">
+                <a:solidFill>
+                  <a:srgbClr val="FFFFFF"/>
+                </a:solidFill>
+                <a:latin typeface="Montserrat"/>
+              </a:rPr>
+              <a:t>&lt; Volver al comparativo</a:t>
+            </a:r>
+          </a:p>
+        </p:txBody>
+      </p:sp>
+      <p:sp>
+        <p:nvSpPr>
+          <p:cNvPr id="8" name="Rectangle 7"/>
           <p:cNvSpPr/>
           <p:nvPr/>
         </p:nvSpPr>
@@ -37678,7 +38613,7 @@
       </p:sp>
       <p:sp>
         <p:nvSpPr>
-          <p:cNvPr id="8" name="Rectangle 7"/>
+          <p:cNvPr id="9" name="Rectangle 8"/>
           <p:cNvSpPr/>
           <p:nvPr/>
         </p:nvSpPr>
@@ -37722,7 +38657,7 @@
       </p:sp>
       <p:sp>
         <p:nvSpPr>
-          <p:cNvPr id="9" name="TextBox 8"/>
+          <p:cNvPr id="10" name="TextBox 9"/>
           <p:cNvSpPr txBox="1"/>
           <p:nvPr/>
         </p:nvSpPr>
@@ -37761,7 +38696,7 @@
       </p:sp>
       <p:sp>
         <p:nvSpPr>
-          <p:cNvPr id="10" name="TextBox 9"/>
+          <p:cNvPr id="11" name="TextBox 10"/>
           <p:cNvSpPr txBox="1"/>
           <p:nvPr/>
         </p:nvSpPr>
@@ -37896,7 +38831,7 @@
       </p:sp>
       <p:sp>
         <p:nvSpPr>
-          <p:cNvPr id="11" name="Rectangle 10"/>
+          <p:cNvPr id="12" name="Rectangle 11"/>
           <p:cNvSpPr/>
           <p:nvPr/>
         </p:nvSpPr>
@@ -37940,7 +38875,7 @@
       </p:sp>
       <p:sp>
         <p:nvSpPr>
-          <p:cNvPr id="12" name="Rectangle 11"/>
+          <p:cNvPr id="13" name="Rectangle 12"/>
           <p:cNvSpPr/>
           <p:nvPr/>
         </p:nvSpPr>
@@ -37984,7 +38919,7 @@
       </p:sp>
       <p:sp>
         <p:nvSpPr>
-          <p:cNvPr id="13" name="TextBox 12"/>
+          <p:cNvPr id="14" name="TextBox 13"/>
           <p:cNvSpPr txBox="1"/>
           <p:nvPr/>
         </p:nvSpPr>
@@ -38023,7 +38958,7 @@
       </p:sp>
       <p:sp>
         <p:nvSpPr>
-          <p:cNvPr id="14" name="TextBox 13"/>
+          <p:cNvPr id="15" name="TextBox 14"/>
           <p:cNvSpPr txBox="1"/>
           <p:nvPr/>
         </p:nvSpPr>
@@ -38176,7 +39111,7 @@
       </p:sp>
       <p:sp>
         <p:nvSpPr>
-          <p:cNvPr id="15" name="TextBox 14"/>
+          <p:cNvPr id="16" name="TextBox 15"/>
           <p:cNvSpPr txBox="1"/>
           <p:nvPr/>
         </p:nvSpPr>
@@ -38211,7 +39146,7 @@
       </p:sp>
       <p:sp>
         <p:nvSpPr>
-          <p:cNvPr id="16" name="Rectangle 15"/>
+          <p:cNvPr id="17" name="Rectangle 16"/>
           <p:cNvSpPr/>
           <p:nvPr/>
         </p:nvSpPr>
@@ -38255,7 +39190,7 @@
       </p:sp>
       <p:sp>
         <p:nvSpPr>
-          <p:cNvPr id="17" name="Rectangle 16"/>
+          <p:cNvPr id="18" name="Rectangle 17"/>
           <p:cNvSpPr/>
           <p:nvPr/>
         </p:nvSpPr>
@@ -38299,7 +39234,7 @@
       </p:sp>
       <p:sp>
         <p:nvSpPr>
-          <p:cNvPr id="18" name="TextBox 17"/>
+          <p:cNvPr id="19" name="TextBox 18"/>
           <p:cNvSpPr txBox="1"/>
           <p:nvPr/>
         </p:nvSpPr>
@@ -38338,7 +39273,7 @@
       </p:sp>
       <p:sp>
         <p:nvSpPr>
-          <p:cNvPr id="19" name="TextBox 18"/>
+          <p:cNvPr id="20" name="TextBox 19"/>
           <p:cNvSpPr txBox="1"/>
           <p:nvPr/>
         </p:nvSpPr>
@@ -38619,7 +39554,62 @@
       </p:sp>
       <p:sp>
         <p:nvSpPr>
-          <p:cNvPr id="7" name="Rectangle 6"/>
+          <p:cNvPr id="7" name="Rounded Rectangle 6">
+            <a:hlinkClick action="ppaction://hlinksldjump" r:id="rId3"/>
+          </p:cNvPr>
+          <p:cNvSpPr/>
+          <p:nvPr/>
+        </p:nvSpPr>
+        <p:spPr>
+          <a:xfrm>
+            <a:off x="9128455" y="457200"/>
+            <a:ext cx="2514600" cy="329184"/>
+          </a:xfrm>
+          <a:prstGeom prst="roundRect">
+            <a:avLst/>
+          </a:prstGeom>
+          <a:solidFill>
+            <a:srgbClr val="6B1531"/>
+          </a:solidFill>
+          <a:ln>
+            <a:noFill/>
+          </a:ln>
+          <a:effectLst/>
+        </p:spPr>
+        <p:style>
+          <a:lnRef idx="1">
+            <a:schemeClr val="accent1"/>
+          </a:lnRef>
+          <a:fillRef idx="3">
+            <a:schemeClr val="accent1"/>
+          </a:fillRef>
+          <a:effectRef idx="2">
+            <a:schemeClr val="accent1"/>
+          </a:effectRef>
+          <a:fontRef idx="minor">
+            <a:schemeClr val="lt1"/>
+          </a:fontRef>
+        </p:style>
+        <p:txBody>
+          <a:bodyPr rtlCol="0" anchor="ctr" lIns="0" rIns="0"/>
+          <a:lstStyle/>
+          <a:p>
+            <a:pPr algn="ctr"/>
+            <a:r>
+              <a:rPr sz="1100" b="1">
+                <a:solidFill>
+                  <a:srgbClr val="FFFFFF"/>
+                </a:solidFill>
+                <a:latin typeface="Montserrat"/>
+              </a:rPr>
+              <a:t>&lt; Volver al comparativo</a:t>
+            </a:r>
+          </a:p>
+        </p:txBody>
+      </p:sp>
+      <p:sp>
+        <p:nvSpPr>
+          <p:cNvPr id="8" name="Rectangle 7"/>
           <p:cNvSpPr/>
           <p:nvPr/>
         </p:nvSpPr>
@@ -38663,7 +39653,7 @@
       </p:sp>
       <p:sp>
         <p:nvSpPr>
-          <p:cNvPr id="8" name="Rectangle 7"/>
+          <p:cNvPr id="9" name="Rectangle 8"/>
           <p:cNvSpPr/>
           <p:nvPr/>
         </p:nvSpPr>
@@ -38707,7 +39697,7 @@
       </p:sp>
       <p:sp>
         <p:nvSpPr>
-          <p:cNvPr id="9" name="TextBox 8"/>
+          <p:cNvPr id="10" name="TextBox 9"/>
           <p:cNvSpPr txBox="1"/>
           <p:nvPr/>
         </p:nvSpPr>
@@ -38746,7 +39736,7 @@
       </p:sp>
       <p:sp>
         <p:nvSpPr>
-          <p:cNvPr id="10" name="TextBox 9"/>
+          <p:cNvPr id="11" name="TextBox 10"/>
           <p:cNvSpPr txBox="1"/>
           <p:nvPr/>
         </p:nvSpPr>
@@ -38807,7 +39797,7 @@
       </p:sp>
       <p:sp>
         <p:nvSpPr>
-          <p:cNvPr id="11" name="Rectangle 10"/>
+          <p:cNvPr id="12" name="Rectangle 11"/>
           <p:cNvSpPr/>
           <p:nvPr/>
         </p:nvSpPr>
@@ -38851,7 +39841,7 @@
       </p:sp>
       <p:sp>
         <p:nvSpPr>
-          <p:cNvPr id="12" name="Rectangle 11"/>
+          <p:cNvPr id="13" name="Rectangle 12"/>
           <p:cNvSpPr/>
           <p:nvPr/>
         </p:nvSpPr>
@@ -38895,7 +39885,7 @@
       </p:sp>
       <p:sp>
         <p:nvSpPr>
-          <p:cNvPr id="13" name="TextBox 12"/>
+          <p:cNvPr id="14" name="TextBox 13"/>
           <p:cNvSpPr txBox="1"/>
           <p:nvPr/>
         </p:nvSpPr>
@@ -38934,7 +39924,7 @@
       </p:sp>
       <p:sp>
         <p:nvSpPr>
-          <p:cNvPr id="14" name="TextBox 13"/>
+          <p:cNvPr id="15" name="TextBox 14"/>
           <p:cNvSpPr txBox="1"/>
           <p:nvPr/>
         </p:nvSpPr>
@@ -38995,7 +39985,7 @@
       </p:sp>
       <p:sp>
         <p:nvSpPr>
-          <p:cNvPr id="15" name="Rectangle 14"/>
+          <p:cNvPr id="16" name="Rectangle 15"/>
           <p:cNvSpPr/>
           <p:nvPr/>
         </p:nvSpPr>
@@ -39039,7 +40029,7 @@
       </p:sp>
       <p:sp>
         <p:nvSpPr>
-          <p:cNvPr id="16" name="Rectangle 15"/>
+          <p:cNvPr id="17" name="Rectangle 16"/>
           <p:cNvSpPr/>
           <p:nvPr/>
         </p:nvSpPr>
@@ -39083,7 +40073,7 @@
       </p:sp>
       <p:sp>
         <p:nvSpPr>
-          <p:cNvPr id="17" name="TextBox 16"/>
+          <p:cNvPr id="18" name="TextBox 17"/>
           <p:cNvSpPr txBox="1"/>
           <p:nvPr/>
         </p:nvSpPr>
@@ -39122,7 +40112,7 @@
       </p:sp>
       <p:sp>
         <p:nvSpPr>
-          <p:cNvPr id="18" name="TextBox 17"/>
+          <p:cNvPr id="19" name="TextBox 18"/>
           <p:cNvSpPr txBox="1"/>
           <p:nvPr/>
         </p:nvSpPr>
@@ -39161,7 +40151,7 @@
       </p:sp>
       <p:sp>
         <p:nvSpPr>
-          <p:cNvPr id="19" name="Rectangle 18"/>
+          <p:cNvPr id="20" name="Rectangle 19"/>
           <p:cNvSpPr/>
           <p:nvPr/>
         </p:nvSpPr>
@@ -39205,7 +40195,7 @@
       </p:sp>
       <p:sp>
         <p:nvSpPr>
-          <p:cNvPr id="20" name="Rectangle 19"/>
+          <p:cNvPr id="21" name="Rectangle 20"/>
           <p:cNvSpPr/>
           <p:nvPr/>
         </p:nvSpPr>
@@ -39249,7 +40239,7 @@
       </p:sp>
       <p:sp>
         <p:nvSpPr>
-          <p:cNvPr id="21" name="TextBox 20"/>
+          <p:cNvPr id="22" name="TextBox 21"/>
           <p:cNvSpPr txBox="1"/>
           <p:nvPr/>
         </p:nvSpPr>
@@ -39288,7 +40278,7 @@
       </p:sp>
       <p:sp>
         <p:nvSpPr>
-          <p:cNvPr id="22" name="TextBox 21"/>
+          <p:cNvPr id="23" name="TextBox 22"/>
           <p:cNvSpPr txBox="1"/>
           <p:nvPr/>
         </p:nvSpPr>
@@ -39327,7 +40317,7 @@
       </p:sp>
       <p:sp>
         <p:nvSpPr>
-          <p:cNvPr id="23" name="TextBox 22"/>
+          <p:cNvPr id="24" name="TextBox 23"/>
           <p:cNvSpPr txBox="1"/>
           <p:nvPr/>
         </p:nvSpPr>
@@ -39362,7 +40352,7 @@
       </p:sp>
       <p:sp>
         <p:nvSpPr>
-          <p:cNvPr id="24" name="Rectangle 23"/>
+          <p:cNvPr id="25" name="Rectangle 24"/>
           <p:cNvSpPr/>
           <p:nvPr/>
         </p:nvSpPr>
@@ -39406,7 +40396,7 @@
       </p:sp>
       <p:sp>
         <p:nvSpPr>
-          <p:cNvPr id="25" name="Rectangle 24"/>
+          <p:cNvPr id="26" name="Rectangle 25"/>
           <p:cNvSpPr/>
           <p:nvPr/>
         </p:nvSpPr>
@@ -39450,7 +40440,7 @@
       </p:sp>
       <p:sp>
         <p:nvSpPr>
-          <p:cNvPr id="26" name="TextBox 25"/>
+          <p:cNvPr id="27" name="TextBox 26"/>
           <p:cNvSpPr txBox="1"/>
           <p:nvPr/>
         </p:nvSpPr>
@@ -39489,7 +40479,7 @@
       </p:sp>
       <p:sp>
         <p:nvSpPr>
-          <p:cNvPr id="27" name="TextBox 26"/>
+          <p:cNvPr id="28" name="TextBox 27"/>
           <p:cNvSpPr txBox="1"/>
           <p:nvPr/>
         </p:nvSpPr>
@@ -39770,7 +40760,62 @@
       </p:sp>
       <p:sp>
         <p:nvSpPr>
-          <p:cNvPr id="7" name="Rectangle 6"/>
+          <p:cNvPr id="7" name="Rounded Rectangle 6">
+            <a:hlinkClick action="ppaction://hlinksldjump" r:id="rId3"/>
+          </p:cNvPr>
+          <p:cNvSpPr/>
+          <p:nvPr/>
+        </p:nvSpPr>
+        <p:spPr>
+          <a:xfrm>
+            <a:off x="9128455" y="457200"/>
+            <a:ext cx="2514600" cy="329184"/>
+          </a:xfrm>
+          <a:prstGeom prst="roundRect">
+            <a:avLst/>
+          </a:prstGeom>
+          <a:solidFill>
+            <a:srgbClr val="6B1531"/>
+          </a:solidFill>
+          <a:ln>
+            <a:noFill/>
+          </a:ln>
+          <a:effectLst/>
+        </p:spPr>
+        <p:style>
+          <a:lnRef idx="1">
+            <a:schemeClr val="accent1"/>
+          </a:lnRef>
+          <a:fillRef idx="3">
+            <a:schemeClr val="accent1"/>
+          </a:fillRef>
+          <a:effectRef idx="2">
+            <a:schemeClr val="accent1"/>
+          </a:effectRef>
+          <a:fontRef idx="minor">
+            <a:schemeClr val="lt1"/>
+          </a:fontRef>
+        </p:style>
+        <p:txBody>
+          <a:bodyPr rtlCol="0" anchor="ctr" lIns="0" rIns="0"/>
+          <a:lstStyle/>
+          <a:p>
+            <a:pPr algn="ctr"/>
+            <a:r>
+              <a:rPr sz="1100" b="1">
+                <a:solidFill>
+                  <a:srgbClr val="FFFFFF"/>
+                </a:solidFill>
+                <a:latin typeface="Montserrat"/>
+              </a:rPr>
+              <a:t>&lt; Volver al comparativo</a:t>
+            </a:r>
+          </a:p>
+        </p:txBody>
+      </p:sp>
+      <p:sp>
+        <p:nvSpPr>
+          <p:cNvPr id="8" name="Rectangle 7"/>
           <p:cNvSpPr/>
           <p:nvPr/>
         </p:nvSpPr>
@@ -39814,7 +40859,7 @@
       </p:sp>
       <p:sp>
         <p:nvSpPr>
-          <p:cNvPr id="8" name="Rectangle 7"/>
+          <p:cNvPr id="9" name="Rectangle 8"/>
           <p:cNvSpPr/>
           <p:nvPr/>
         </p:nvSpPr>
@@ -39858,7 +40903,7 @@
       </p:sp>
       <p:sp>
         <p:nvSpPr>
-          <p:cNvPr id="9" name="TextBox 8"/>
+          <p:cNvPr id="10" name="TextBox 9"/>
           <p:cNvSpPr txBox="1"/>
           <p:nvPr/>
         </p:nvSpPr>
@@ -39897,7 +40942,7 @@
       </p:sp>
       <p:sp>
         <p:nvSpPr>
-          <p:cNvPr id="10" name="TextBox 9"/>
+          <p:cNvPr id="11" name="TextBox 10"/>
           <p:cNvSpPr txBox="1"/>
           <p:nvPr/>
         </p:nvSpPr>
@@ -39977,7 +41022,7 @@
       </p:sp>
       <p:sp>
         <p:nvSpPr>
-          <p:cNvPr id="11" name="Rectangle 10"/>
+          <p:cNvPr id="12" name="Rectangle 11"/>
           <p:cNvSpPr/>
           <p:nvPr/>
         </p:nvSpPr>
@@ -40021,7 +41066,7 @@
       </p:sp>
       <p:sp>
         <p:nvSpPr>
-          <p:cNvPr id="12" name="Rectangle 11"/>
+          <p:cNvPr id="13" name="Rectangle 12"/>
           <p:cNvSpPr/>
           <p:nvPr/>
         </p:nvSpPr>
@@ -40065,7 +41110,7 @@
       </p:sp>
       <p:sp>
         <p:nvSpPr>
-          <p:cNvPr id="13" name="TextBox 12"/>
+          <p:cNvPr id="14" name="TextBox 13"/>
           <p:cNvSpPr txBox="1"/>
           <p:nvPr/>
         </p:nvSpPr>
@@ -40104,7 +41149,7 @@
       </p:sp>
       <p:sp>
         <p:nvSpPr>
-          <p:cNvPr id="14" name="TextBox 13"/>
+          <p:cNvPr id="15" name="TextBox 14"/>
           <p:cNvSpPr txBox="1"/>
           <p:nvPr/>
         </p:nvSpPr>
@@ -40184,7 +41229,7 @@
       </p:sp>
       <p:sp>
         <p:nvSpPr>
-          <p:cNvPr id="15" name="TextBox 14"/>
+          <p:cNvPr id="16" name="TextBox 15"/>
           <p:cNvSpPr txBox="1"/>
           <p:nvPr/>
         </p:nvSpPr>
@@ -40219,7 +41264,7 @@
       </p:sp>
       <p:sp>
         <p:nvSpPr>
-          <p:cNvPr id="16" name="Rectangle 15"/>
+          <p:cNvPr id="17" name="Rectangle 16"/>
           <p:cNvSpPr/>
           <p:nvPr/>
         </p:nvSpPr>
@@ -40263,7 +41308,7 @@
       </p:sp>
       <p:sp>
         <p:nvSpPr>
-          <p:cNvPr id="17" name="Rectangle 16"/>
+          <p:cNvPr id="18" name="Rectangle 17"/>
           <p:cNvSpPr/>
           <p:nvPr/>
         </p:nvSpPr>
@@ -40307,7 +41352,7 @@
       </p:sp>
       <p:sp>
         <p:nvSpPr>
-          <p:cNvPr id="18" name="TextBox 17"/>
+          <p:cNvPr id="19" name="TextBox 18"/>
           <p:cNvSpPr txBox="1"/>
           <p:nvPr/>
         </p:nvSpPr>
@@ -40346,7 +41391,7 @@
       </p:sp>
       <p:sp>
         <p:nvSpPr>
-          <p:cNvPr id="19" name="TextBox 18"/>
+          <p:cNvPr id="20" name="TextBox 19"/>
           <p:cNvSpPr txBox="1"/>
           <p:nvPr/>
         </p:nvSpPr>
@@ -41580,7 +42625,62 @@
       </p:sp>
       <p:sp>
         <p:nvSpPr>
-          <p:cNvPr id="7" name="Rectangle 6"/>
+          <p:cNvPr id="7" name="Rounded Rectangle 6">
+            <a:hlinkClick action="ppaction://hlinksldjump" r:id="rId3"/>
+          </p:cNvPr>
+          <p:cNvSpPr/>
+          <p:nvPr/>
+        </p:nvSpPr>
+        <p:spPr>
+          <a:xfrm>
+            <a:off x="9128455" y="457200"/>
+            <a:ext cx="2514600" cy="329184"/>
+          </a:xfrm>
+          <a:prstGeom prst="roundRect">
+            <a:avLst/>
+          </a:prstGeom>
+          <a:solidFill>
+            <a:srgbClr val="6B1531"/>
+          </a:solidFill>
+          <a:ln>
+            <a:noFill/>
+          </a:ln>
+          <a:effectLst/>
+        </p:spPr>
+        <p:style>
+          <a:lnRef idx="1">
+            <a:schemeClr val="accent1"/>
+          </a:lnRef>
+          <a:fillRef idx="3">
+            <a:schemeClr val="accent1"/>
+          </a:fillRef>
+          <a:effectRef idx="2">
+            <a:schemeClr val="accent1"/>
+          </a:effectRef>
+          <a:fontRef idx="minor">
+            <a:schemeClr val="lt1"/>
+          </a:fontRef>
+        </p:style>
+        <p:txBody>
+          <a:bodyPr rtlCol="0" anchor="ctr" lIns="0" rIns="0"/>
+          <a:lstStyle/>
+          <a:p>
+            <a:pPr algn="ctr"/>
+            <a:r>
+              <a:rPr sz="1100" b="1">
+                <a:solidFill>
+                  <a:srgbClr val="FFFFFF"/>
+                </a:solidFill>
+                <a:latin typeface="Montserrat"/>
+              </a:rPr>
+              <a:t>&lt; Volver al comparativo</a:t>
+            </a:r>
+          </a:p>
+        </p:txBody>
+      </p:sp>
+      <p:sp>
+        <p:nvSpPr>
+          <p:cNvPr id="8" name="Rectangle 7"/>
           <p:cNvSpPr/>
           <p:nvPr/>
         </p:nvSpPr>
@@ -41624,7 +42724,7 @@
       </p:sp>
       <p:sp>
         <p:nvSpPr>
-          <p:cNvPr id="8" name="Rectangle 7"/>
+          <p:cNvPr id="9" name="Rectangle 8"/>
           <p:cNvSpPr/>
           <p:nvPr/>
         </p:nvSpPr>
@@ -41668,7 +42768,7 @@
       </p:sp>
       <p:sp>
         <p:nvSpPr>
-          <p:cNvPr id="9" name="TextBox 8"/>
+          <p:cNvPr id="10" name="TextBox 9"/>
           <p:cNvSpPr txBox="1"/>
           <p:nvPr/>
         </p:nvSpPr>
@@ -41707,7 +42807,7 @@
       </p:sp>
       <p:sp>
         <p:nvSpPr>
-          <p:cNvPr id="10" name="TextBox 9"/>
+          <p:cNvPr id="11" name="TextBox 10"/>
           <p:cNvSpPr txBox="1"/>
           <p:nvPr/>
         </p:nvSpPr>
@@ -41786,7 +42886,7 @@
       </p:sp>
       <p:sp>
         <p:nvSpPr>
-          <p:cNvPr id="11" name="Rectangle 10"/>
+          <p:cNvPr id="12" name="Rectangle 11"/>
           <p:cNvSpPr/>
           <p:nvPr/>
         </p:nvSpPr>
@@ -41830,7 +42930,7 @@
       </p:sp>
       <p:sp>
         <p:nvSpPr>
-          <p:cNvPr id="12" name="Rectangle 11"/>
+          <p:cNvPr id="13" name="Rectangle 12"/>
           <p:cNvSpPr/>
           <p:nvPr/>
         </p:nvSpPr>
@@ -41874,7 +42974,7 @@
       </p:sp>
       <p:sp>
         <p:nvSpPr>
-          <p:cNvPr id="13" name="TextBox 12"/>
+          <p:cNvPr id="14" name="TextBox 13"/>
           <p:cNvSpPr txBox="1"/>
           <p:nvPr/>
         </p:nvSpPr>
@@ -41913,7 +43013,7 @@
       </p:sp>
       <p:sp>
         <p:nvSpPr>
-          <p:cNvPr id="14" name="TextBox 13"/>
+          <p:cNvPr id="15" name="TextBox 14"/>
           <p:cNvSpPr txBox="1"/>
           <p:nvPr/>
         </p:nvSpPr>
@@ -41983,7 +43083,7 @@
       </p:sp>
       <p:sp>
         <p:nvSpPr>
-          <p:cNvPr id="15" name="TextBox 14"/>
+          <p:cNvPr id="16" name="TextBox 15"/>
           <p:cNvSpPr txBox="1"/>
           <p:nvPr/>
         </p:nvSpPr>
@@ -42018,7 +43118,7 @@
       </p:sp>
       <p:sp>
         <p:nvSpPr>
-          <p:cNvPr id="16" name="Rectangle 15"/>
+          <p:cNvPr id="17" name="Rectangle 16"/>
           <p:cNvSpPr/>
           <p:nvPr/>
         </p:nvSpPr>
@@ -42062,7 +43162,7 @@
       </p:sp>
       <p:sp>
         <p:nvSpPr>
-          <p:cNvPr id="17" name="Rectangle 16"/>
+          <p:cNvPr id="18" name="Rectangle 17"/>
           <p:cNvSpPr/>
           <p:nvPr/>
         </p:nvSpPr>
@@ -42106,7 +43206,7 @@
       </p:sp>
       <p:sp>
         <p:nvSpPr>
-          <p:cNvPr id="18" name="TextBox 17"/>
+          <p:cNvPr id="19" name="TextBox 18"/>
           <p:cNvSpPr txBox="1"/>
           <p:nvPr/>
         </p:nvSpPr>
@@ -42145,7 +43245,7 @@
       </p:sp>
       <p:sp>
         <p:nvSpPr>
-          <p:cNvPr id="19" name="TextBox 18"/>
+          <p:cNvPr id="20" name="TextBox 19"/>
           <p:cNvSpPr txBox="1"/>
           <p:nvPr/>
         </p:nvSpPr>
@@ -42426,7 +43526,62 @@
       </p:sp>
       <p:sp>
         <p:nvSpPr>
-          <p:cNvPr id="7" name="Rectangle 6"/>
+          <p:cNvPr id="7" name="Rounded Rectangle 6">
+            <a:hlinkClick action="ppaction://hlinksldjump" r:id="rId3"/>
+          </p:cNvPr>
+          <p:cNvSpPr/>
+          <p:nvPr/>
+        </p:nvSpPr>
+        <p:spPr>
+          <a:xfrm>
+            <a:off x="9128455" y="457200"/>
+            <a:ext cx="2514600" cy="329184"/>
+          </a:xfrm>
+          <a:prstGeom prst="roundRect">
+            <a:avLst/>
+          </a:prstGeom>
+          <a:solidFill>
+            <a:srgbClr val="6B1531"/>
+          </a:solidFill>
+          <a:ln>
+            <a:noFill/>
+          </a:ln>
+          <a:effectLst/>
+        </p:spPr>
+        <p:style>
+          <a:lnRef idx="1">
+            <a:schemeClr val="accent1"/>
+          </a:lnRef>
+          <a:fillRef idx="3">
+            <a:schemeClr val="accent1"/>
+          </a:fillRef>
+          <a:effectRef idx="2">
+            <a:schemeClr val="accent1"/>
+          </a:effectRef>
+          <a:fontRef idx="minor">
+            <a:schemeClr val="lt1"/>
+          </a:fontRef>
+        </p:style>
+        <p:txBody>
+          <a:bodyPr rtlCol="0" anchor="ctr" lIns="0" rIns="0"/>
+          <a:lstStyle/>
+          <a:p>
+            <a:pPr algn="ctr"/>
+            <a:r>
+              <a:rPr sz="1100" b="1">
+                <a:solidFill>
+                  <a:srgbClr val="FFFFFF"/>
+                </a:solidFill>
+                <a:latin typeface="Montserrat"/>
+              </a:rPr>
+              <a:t>&lt; Volver al comparativo</a:t>
+            </a:r>
+          </a:p>
+        </p:txBody>
+      </p:sp>
+      <p:sp>
+        <p:nvSpPr>
+          <p:cNvPr id="8" name="Rectangle 7"/>
           <p:cNvSpPr/>
           <p:nvPr/>
         </p:nvSpPr>
@@ -42470,7 +43625,7 @@
       </p:sp>
       <p:sp>
         <p:nvSpPr>
-          <p:cNvPr id="8" name="Rectangle 7"/>
+          <p:cNvPr id="9" name="Rectangle 8"/>
           <p:cNvSpPr/>
           <p:nvPr/>
         </p:nvSpPr>
@@ -42514,7 +43669,7 @@
       </p:sp>
       <p:sp>
         <p:nvSpPr>
-          <p:cNvPr id="9" name="TextBox 8"/>
+          <p:cNvPr id="10" name="TextBox 9"/>
           <p:cNvSpPr txBox="1"/>
           <p:nvPr/>
         </p:nvSpPr>
@@ -42553,7 +43708,7 @@
       </p:sp>
       <p:sp>
         <p:nvSpPr>
-          <p:cNvPr id="10" name="TextBox 9"/>
+          <p:cNvPr id="11" name="TextBox 10"/>
           <p:cNvSpPr txBox="1"/>
           <p:nvPr/>
         </p:nvSpPr>
@@ -42595,7 +43750,7 @@
       </p:sp>
       <p:sp>
         <p:nvSpPr>
-          <p:cNvPr id="11" name="Rectangle 10"/>
+          <p:cNvPr id="12" name="Rectangle 11"/>
           <p:cNvSpPr/>
           <p:nvPr/>
         </p:nvSpPr>
@@ -42639,7 +43794,7 @@
       </p:sp>
       <p:sp>
         <p:nvSpPr>
-          <p:cNvPr id="12" name="Rectangle 11"/>
+          <p:cNvPr id="13" name="Rectangle 12"/>
           <p:cNvSpPr/>
           <p:nvPr/>
         </p:nvSpPr>
@@ -42683,7 +43838,7 @@
       </p:sp>
       <p:sp>
         <p:nvSpPr>
-          <p:cNvPr id="13" name="TextBox 12"/>
+          <p:cNvPr id="14" name="TextBox 13"/>
           <p:cNvSpPr txBox="1"/>
           <p:nvPr/>
         </p:nvSpPr>
@@ -42722,7 +43877,7 @@
       </p:sp>
       <p:sp>
         <p:nvSpPr>
-          <p:cNvPr id="14" name="TextBox 13"/>
+          <p:cNvPr id="15" name="TextBox 14"/>
           <p:cNvSpPr txBox="1"/>
           <p:nvPr/>
         </p:nvSpPr>
@@ -42764,7 +43919,7 @@
       </p:sp>
       <p:sp>
         <p:nvSpPr>
-          <p:cNvPr id="15" name="Rectangle 14"/>
+          <p:cNvPr id="16" name="Rectangle 15"/>
           <p:cNvSpPr/>
           <p:nvPr/>
         </p:nvSpPr>
@@ -42808,7 +43963,7 @@
       </p:sp>
       <p:sp>
         <p:nvSpPr>
-          <p:cNvPr id="16" name="Rectangle 15"/>
+          <p:cNvPr id="17" name="Rectangle 16"/>
           <p:cNvSpPr/>
           <p:nvPr/>
         </p:nvSpPr>
@@ -42852,7 +44007,7 @@
       </p:sp>
       <p:sp>
         <p:nvSpPr>
-          <p:cNvPr id="17" name="TextBox 16"/>
+          <p:cNvPr id="18" name="TextBox 17"/>
           <p:cNvSpPr txBox="1"/>
           <p:nvPr/>
         </p:nvSpPr>
@@ -42891,7 +44046,7 @@
       </p:sp>
       <p:sp>
         <p:nvSpPr>
-          <p:cNvPr id="18" name="TextBox 17"/>
+          <p:cNvPr id="19" name="TextBox 18"/>
           <p:cNvSpPr txBox="1"/>
           <p:nvPr/>
         </p:nvSpPr>
@@ -42930,7 +44085,7 @@
       </p:sp>
       <p:sp>
         <p:nvSpPr>
-          <p:cNvPr id="19" name="Rectangle 18"/>
+          <p:cNvPr id="20" name="Rectangle 19"/>
           <p:cNvSpPr/>
           <p:nvPr/>
         </p:nvSpPr>
@@ -42974,7 +44129,7 @@
       </p:sp>
       <p:sp>
         <p:nvSpPr>
-          <p:cNvPr id="20" name="Rectangle 19"/>
+          <p:cNvPr id="21" name="Rectangle 20"/>
           <p:cNvSpPr/>
           <p:nvPr/>
         </p:nvSpPr>
@@ -43018,7 +44173,7 @@
       </p:sp>
       <p:sp>
         <p:nvSpPr>
-          <p:cNvPr id="21" name="TextBox 20"/>
+          <p:cNvPr id="22" name="TextBox 21"/>
           <p:cNvSpPr txBox="1"/>
           <p:nvPr/>
         </p:nvSpPr>
@@ -43057,7 +44212,7 @@
       </p:sp>
       <p:sp>
         <p:nvSpPr>
-          <p:cNvPr id="22" name="TextBox 21"/>
+          <p:cNvPr id="23" name="TextBox 22"/>
           <p:cNvSpPr txBox="1"/>
           <p:nvPr/>
         </p:nvSpPr>
@@ -43096,7 +44251,7 @@
       </p:sp>
       <p:sp>
         <p:nvSpPr>
-          <p:cNvPr id="23" name="TextBox 22"/>
+          <p:cNvPr id="24" name="TextBox 23"/>
           <p:cNvSpPr txBox="1"/>
           <p:nvPr/>
         </p:nvSpPr>
@@ -43131,7 +44286,7 @@
       </p:sp>
       <p:sp>
         <p:nvSpPr>
-          <p:cNvPr id="24" name="Rectangle 23"/>
+          <p:cNvPr id="25" name="Rectangle 24"/>
           <p:cNvSpPr/>
           <p:nvPr/>
         </p:nvSpPr>
@@ -43175,7 +44330,7 @@
       </p:sp>
       <p:sp>
         <p:nvSpPr>
-          <p:cNvPr id="25" name="Rectangle 24"/>
+          <p:cNvPr id="26" name="Rectangle 25"/>
           <p:cNvSpPr/>
           <p:nvPr/>
         </p:nvSpPr>
@@ -43219,7 +44374,7 @@
       </p:sp>
       <p:sp>
         <p:nvSpPr>
-          <p:cNvPr id="26" name="TextBox 25"/>
+          <p:cNvPr id="27" name="TextBox 26"/>
           <p:cNvSpPr txBox="1"/>
           <p:nvPr/>
         </p:nvSpPr>
@@ -43258,7 +44413,7 @@
       </p:sp>
       <p:sp>
         <p:nvSpPr>
-          <p:cNvPr id="27" name="TextBox 26"/>
+          <p:cNvPr id="28" name="TextBox 27"/>
           <p:cNvSpPr txBox="1"/>
           <p:nvPr/>
         </p:nvSpPr>
@@ -43539,7 +44694,62 @@
       </p:sp>
       <p:sp>
         <p:nvSpPr>
-          <p:cNvPr id="7" name="Rectangle 6"/>
+          <p:cNvPr id="7" name="Rounded Rectangle 6">
+            <a:hlinkClick action="ppaction://hlinksldjump" r:id="rId3"/>
+          </p:cNvPr>
+          <p:cNvSpPr/>
+          <p:nvPr/>
+        </p:nvSpPr>
+        <p:spPr>
+          <a:xfrm>
+            <a:off x="9128455" y="457200"/>
+            <a:ext cx="2514600" cy="329184"/>
+          </a:xfrm>
+          <a:prstGeom prst="roundRect">
+            <a:avLst/>
+          </a:prstGeom>
+          <a:solidFill>
+            <a:srgbClr val="6B1531"/>
+          </a:solidFill>
+          <a:ln>
+            <a:noFill/>
+          </a:ln>
+          <a:effectLst/>
+        </p:spPr>
+        <p:style>
+          <a:lnRef idx="1">
+            <a:schemeClr val="accent1"/>
+          </a:lnRef>
+          <a:fillRef idx="3">
+            <a:schemeClr val="accent1"/>
+          </a:fillRef>
+          <a:effectRef idx="2">
+            <a:schemeClr val="accent1"/>
+          </a:effectRef>
+          <a:fontRef idx="minor">
+            <a:schemeClr val="lt1"/>
+          </a:fontRef>
+        </p:style>
+        <p:txBody>
+          <a:bodyPr rtlCol="0" anchor="ctr" lIns="0" rIns="0"/>
+          <a:lstStyle/>
+          <a:p>
+            <a:pPr algn="ctr"/>
+            <a:r>
+              <a:rPr sz="1100" b="1">
+                <a:solidFill>
+                  <a:srgbClr val="FFFFFF"/>
+                </a:solidFill>
+                <a:latin typeface="Montserrat"/>
+              </a:rPr>
+              <a:t>&lt; Volver al comparativo</a:t>
+            </a:r>
+          </a:p>
+        </p:txBody>
+      </p:sp>
+      <p:sp>
+        <p:nvSpPr>
+          <p:cNvPr id="8" name="Rectangle 7"/>
           <p:cNvSpPr/>
           <p:nvPr/>
         </p:nvSpPr>
@@ -43583,7 +44793,7 @@
       </p:sp>
       <p:sp>
         <p:nvSpPr>
-          <p:cNvPr id="8" name="Rectangle 7"/>
+          <p:cNvPr id="9" name="Rectangle 8"/>
           <p:cNvSpPr/>
           <p:nvPr/>
         </p:nvSpPr>
@@ -43627,7 +44837,7 @@
       </p:sp>
       <p:sp>
         <p:nvSpPr>
-          <p:cNvPr id="9" name="TextBox 8"/>
+          <p:cNvPr id="10" name="TextBox 9"/>
           <p:cNvSpPr txBox="1"/>
           <p:nvPr/>
         </p:nvSpPr>
@@ -43666,7 +44876,7 @@
       </p:sp>
       <p:sp>
         <p:nvSpPr>
-          <p:cNvPr id="10" name="TextBox 9"/>
+          <p:cNvPr id="11" name="TextBox 10"/>
           <p:cNvSpPr txBox="1"/>
           <p:nvPr/>
         </p:nvSpPr>
@@ -43726,7 +44936,7 @@
       </p:sp>
       <p:sp>
         <p:nvSpPr>
-          <p:cNvPr id="11" name="Rectangle 10"/>
+          <p:cNvPr id="12" name="Rectangle 11"/>
           <p:cNvSpPr/>
           <p:nvPr/>
         </p:nvSpPr>
@@ -43770,7 +44980,7 @@
       </p:sp>
       <p:sp>
         <p:nvSpPr>
-          <p:cNvPr id="12" name="Rectangle 11"/>
+          <p:cNvPr id="13" name="Rectangle 12"/>
           <p:cNvSpPr/>
           <p:nvPr/>
         </p:nvSpPr>
@@ -43814,7 +45024,7 @@
       </p:sp>
       <p:sp>
         <p:nvSpPr>
-          <p:cNvPr id="13" name="TextBox 12"/>
+          <p:cNvPr id="14" name="TextBox 13"/>
           <p:cNvSpPr txBox="1"/>
           <p:nvPr/>
         </p:nvSpPr>
@@ -43853,7 +45063,7 @@
       </p:sp>
       <p:sp>
         <p:nvSpPr>
-          <p:cNvPr id="14" name="TextBox 13"/>
+          <p:cNvPr id="15" name="TextBox 14"/>
           <p:cNvSpPr txBox="1"/>
           <p:nvPr/>
         </p:nvSpPr>
@@ -43904,7 +45114,7 @@
       </p:sp>
       <p:sp>
         <p:nvSpPr>
-          <p:cNvPr id="15" name="TextBox 14"/>
+          <p:cNvPr id="16" name="TextBox 15"/>
           <p:cNvSpPr txBox="1"/>
           <p:nvPr/>
         </p:nvSpPr>
@@ -43939,7 +45149,7 @@
       </p:sp>
       <p:sp>
         <p:nvSpPr>
-          <p:cNvPr id="16" name="Rectangle 15"/>
+          <p:cNvPr id="17" name="Rectangle 16"/>
           <p:cNvSpPr/>
           <p:nvPr/>
         </p:nvSpPr>
@@ -43983,7 +45193,7 @@
       </p:sp>
       <p:sp>
         <p:nvSpPr>
-          <p:cNvPr id="17" name="Rectangle 16"/>
+          <p:cNvPr id="18" name="Rectangle 17"/>
           <p:cNvSpPr/>
           <p:nvPr/>
         </p:nvSpPr>
@@ -44027,7 +45237,7 @@
       </p:sp>
       <p:sp>
         <p:nvSpPr>
-          <p:cNvPr id="18" name="TextBox 17"/>
+          <p:cNvPr id="19" name="TextBox 18"/>
           <p:cNvSpPr txBox="1"/>
           <p:nvPr/>
         </p:nvSpPr>
@@ -44066,7 +45276,7 @@
       </p:sp>
       <p:sp>
         <p:nvSpPr>
-          <p:cNvPr id="19" name="TextBox 18"/>
+          <p:cNvPr id="20" name="TextBox 19"/>
           <p:cNvSpPr txBox="1"/>
           <p:nvPr/>
         </p:nvSpPr>
@@ -44347,7 +45557,62 @@
       </p:sp>
       <p:sp>
         <p:nvSpPr>
-          <p:cNvPr id="7" name="Rectangle 6"/>
+          <p:cNvPr id="7" name="Rounded Rectangle 6">
+            <a:hlinkClick action="ppaction://hlinksldjump" r:id="rId3"/>
+          </p:cNvPr>
+          <p:cNvSpPr/>
+          <p:nvPr/>
+        </p:nvSpPr>
+        <p:spPr>
+          <a:xfrm>
+            <a:off x="9128455" y="457200"/>
+            <a:ext cx="2514600" cy="329184"/>
+          </a:xfrm>
+          <a:prstGeom prst="roundRect">
+            <a:avLst/>
+          </a:prstGeom>
+          <a:solidFill>
+            <a:srgbClr val="6B1531"/>
+          </a:solidFill>
+          <a:ln>
+            <a:noFill/>
+          </a:ln>
+          <a:effectLst/>
+        </p:spPr>
+        <p:style>
+          <a:lnRef idx="1">
+            <a:schemeClr val="accent1"/>
+          </a:lnRef>
+          <a:fillRef idx="3">
+            <a:schemeClr val="accent1"/>
+          </a:fillRef>
+          <a:effectRef idx="2">
+            <a:schemeClr val="accent1"/>
+          </a:effectRef>
+          <a:fontRef idx="minor">
+            <a:schemeClr val="lt1"/>
+          </a:fontRef>
+        </p:style>
+        <p:txBody>
+          <a:bodyPr rtlCol="0" anchor="ctr" lIns="0" rIns="0"/>
+          <a:lstStyle/>
+          <a:p>
+            <a:pPr algn="ctr"/>
+            <a:r>
+              <a:rPr sz="1100" b="1">
+                <a:solidFill>
+                  <a:srgbClr val="FFFFFF"/>
+                </a:solidFill>
+                <a:latin typeface="Montserrat"/>
+              </a:rPr>
+              <a:t>&lt; Volver al comparativo</a:t>
+            </a:r>
+          </a:p>
+        </p:txBody>
+      </p:sp>
+      <p:sp>
+        <p:nvSpPr>
+          <p:cNvPr id="8" name="Rectangle 7"/>
           <p:cNvSpPr/>
           <p:nvPr/>
         </p:nvSpPr>
@@ -44391,7 +45656,7 @@
       </p:sp>
       <p:sp>
         <p:nvSpPr>
-          <p:cNvPr id="8" name="Rectangle 7"/>
+          <p:cNvPr id="9" name="Rectangle 8"/>
           <p:cNvSpPr/>
           <p:nvPr/>
         </p:nvSpPr>
@@ -44435,7 +45700,7 @@
       </p:sp>
       <p:sp>
         <p:nvSpPr>
-          <p:cNvPr id="9" name="TextBox 8"/>
+          <p:cNvPr id="10" name="TextBox 9"/>
           <p:cNvSpPr txBox="1"/>
           <p:nvPr/>
         </p:nvSpPr>
@@ -44474,7 +45739,7 @@
       </p:sp>
       <p:sp>
         <p:nvSpPr>
-          <p:cNvPr id="10" name="TextBox 9"/>
+          <p:cNvPr id="11" name="TextBox 10"/>
           <p:cNvSpPr txBox="1"/>
           <p:nvPr/>
         </p:nvSpPr>
@@ -44516,7 +45781,7 @@
       </p:sp>
       <p:sp>
         <p:nvSpPr>
-          <p:cNvPr id="11" name="Rectangle 10"/>
+          <p:cNvPr id="12" name="Rectangle 11"/>
           <p:cNvSpPr/>
           <p:nvPr/>
         </p:nvSpPr>
@@ -44560,7 +45825,7 @@
       </p:sp>
       <p:sp>
         <p:nvSpPr>
-          <p:cNvPr id="12" name="Rectangle 11"/>
+          <p:cNvPr id="13" name="Rectangle 12"/>
           <p:cNvSpPr/>
           <p:nvPr/>
         </p:nvSpPr>
@@ -44604,7 +45869,7 @@
       </p:sp>
       <p:sp>
         <p:nvSpPr>
-          <p:cNvPr id="13" name="TextBox 12"/>
+          <p:cNvPr id="14" name="TextBox 13"/>
           <p:cNvSpPr txBox="1"/>
           <p:nvPr/>
         </p:nvSpPr>
@@ -44643,7 +45908,7 @@
       </p:sp>
       <p:sp>
         <p:nvSpPr>
-          <p:cNvPr id="14" name="TextBox 13"/>
+          <p:cNvPr id="15" name="TextBox 14"/>
           <p:cNvSpPr txBox="1"/>
           <p:nvPr/>
         </p:nvSpPr>
@@ -44685,7 +45950,7 @@
       </p:sp>
       <p:sp>
         <p:nvSpPr>
-          <p:cNvPr id="15" name="Rectangle 14"/>
+          <p:cNvPr id="16" name="Rectangle 15"/>
           <p:cNvSpPr/>
           <p:nvPr/>
         </p:nvSpPr>
@@ -44729,7 +45994,7 @@
       </p:sp>
       <p:sp>
         <p:nvSpPr>
-          <p:cNvPr id="16" name="Rectangle 15"/>
+          <p:cNvPr id="17" name="Rectangle 16"/>
           <p:cNvSpPr/>
           <p:nvPr/>
         </p:nvSpPr>
@@ -44773,7 +46038,7 @@
       </p:sp>
       <p:sp>
         <p:nvSpPr>
-          <p:cNvPr id="17" name="TextBox 16"/>
+          <p:cNvPr id="18" name="TextBox 17"/>
           <p:cNvSpPr txBox="1"/>
           <p:nvPr/>
         </p:nvSpPr>
@@ -44812,7 +46077,7 @@
       </p:sp>
       <p:sp>
         <p:nvSpPr>
-          <p:cNvPr id="18" name="TextBox 17"/>
+          <p:cNvPr id="19" name="TextBox 18"/>
           <p:cNvSpPr txBox="1"/>
           <p:nvPr/>
         </p:nvSpPr>
@@ -44851,7 +46116,7 @@
       </p:sp>
       <p:sp>
         <p:nvSpPr>
-          <p:cNvPr id="19" name="Rectangle 18"/>
+          <p:cNvPr id="20" name="Rectangle 19"/>
           <p:cNvSpPr/>
           <p:nvPr/>
         </p:nvSpPr>
@@ -44895,7 +46160,7 @@
       </p:sp>
       <p:sp>
         <p:nvSpPr>
-          <p:cNvPr id="20" name="Rectangle 19"/>
+          <p:cNvPr id="21" name="Rectangle 20"/>
           <p:cNvSpPr/>
           <p:nvPr/>
         </p:nvSpPr>
@@ -44939,7 +46204,7 @@
       </p:sp>
       <p:sp>
         <p:nvSpPr>
-          <p:cNvPr id="21" name="TextBox 20"/>
+          <p:cNvPr id="22" name="TextBox 21"/>
           <p:cNvSpPr txBox="1"/>
           <p:nvPr/>
         </p:nvSpPr>
@@ -44978,7 +46243,7 @@
       </p:sp>
       <p:sp>
         <p:nvSpPr>
-          <p:cNvPr id="22" name="TextBox 21"/>
+          <p:cNvPr id="23" name="TextBox 22"/>
           <p:cNvSpPr txBox="1"/>
           <p:nvPr/>
         </p:nvSpPr>
@@ -45017,7 +46282,7 @@
       </p:sp>
       <p:sp>
         <p:nvSpPr>
-          <p:cNvPr id="23" name="TextBox 22"/>
+          <p:cNvPr id="24" name="TextBox 23"/>
           <p:cNvSpPr txBox="1"/>
           <p:nvPr/>
         </p:nvSpPr>
@@ -45052,7 +46317,7 @@
       </p:sp>
       <p:sp>
         <p:nvSpPr>
-          <p:cNvPr id="24" name="Rectangle 23"/>
+          <p:cNvPr id="25" name="Rectangle 24"/>
           <p:cNvSpPr/>
           <p:nvPr/>
         </p:nvSpPr>
@@ -45096,7 +46361,7 @@
       </p:sp>
       <p:sp>
         <p:nvSpPr>
-          <p:cNvPr id="25" name="Rectangle 24"/>
+          <p:cNvPr id="26" name="Rectangle 25"/>
           <p:cNvSpPr/>
           <p:nvPr/>
         </p:nvSpPr>
@@ -45140,7 +46405,7 @@
       </p:sp>
       <p:sp>
         <p:nvSpPr>
-          <p:cNvPr id="26" name="TextBox 25"/>
+          <p:cNvPr id="27" name="TextBox 26"/>
           <p:cNvSpPr txBox="1"/>
           <p:nvPr/>
         </p:nvSpPr>
@@ -45179,7 +46444,7 @@
       </p:sp>
       <p:sp>
         <p:nvSpPr>
-          <p:cNvPr id="27" name="TextBox 26"/>
+          <p:cNvPr id="28" name="TextBox 27"/>
           <p:cNvSpPr txBox="1"/>
           <p:nvPr/>
         </p:nvSpPr>

</xml_diff>